<commit_message>
LSA Geomorphology L1-L16, FS1 and FS2 rewritten along the syllabus in the validated style
Co-Authored-By: Claude Opus 5.5 <noreply@anthropic.com>
Claude-Session: https://claude.ai/code/session_0115LFSb2ktGLWPeVksFkSer
</commit_message>
<xml_diff>
--- a/lecons/LSA/Geomorphology/01_LSA_GEOMO_L01_Origin_of_the_Earth.pptx
+++ b/lecons/LSA/Geomorphology/01_LSA_GEOMO_L01_Origin_of_the_Earth.pptx
@@ -67,11 +67,9 @@
     <p:sldId id="315" r:id="rId61"/>
     <p:sldId id="316" r:id="rId62"/>
     <p:sldId id="317" r:id="rId63"/>
-    <p:sldId id="318" r:id="rId64"/>
-    <p:sldId id="319" r:id="rId65"/>
   </p:sldIdLst>
   <p:notesMasterIdLst>
-    <p:notesMasterId r:id="rId66"/>
+    <p:notesMasterId r:id="rId64"/>
   </p:notesMasterIdLst>
   <p:sldSz cx="12192000" cy="6858000"/>
   <p:notesSz cx="6858000" cy="12192000"/>
@@ -3381,7 +3379,7 @@
           <a:p>
             <a:r>
               <a:rPr lang="en-US" dirty="0"/>
-              <a:t>Let us copy Introduction to Geomorphology. The branches and processes of geomorphology are the following. Copy the point on Structural geomorphology on the left, then draw the diagram on the right: the two branches. Give it a title and label it clearly.</a:t>
+              <a:t>Let us copy Meaning of Geomorphology. Geomorphology is explained as follows. Copy the point on Geomorphology on the left, then draw the diagram on the right: the branches of geomorphology. Give it a title and label it clearly.</a:t>
             </a:r>
             <a:endParaRPr lang="en-US" dirty="0"/>
           </a:p>
@@ -3557,7 +3555,7 @@
           <a:p>
             <a:r>
               <a:rPr lang="en-US" dirty="0"/>
-              <a:t>We continue with Introduction to Geomorphology. On this slide we have Dynamic geomorphology. Write each point on a new line, with the key term first, and explain it in your own words when we revise.</a:t>
+              <a:t>We continue with Meaning of Geomorphology. Copy the point on Its scope: write the key term first, then its explanation.</a:t>
             </a:r>
             <a:endParaRPr lang="en-US" dirty="0"/>
           </a:p>
@@ -3645,7 +3643,7 @@
           <a:p>
             <a:r>
               <a:rPr lang="en-US" dirty="0"/>
-              <a:t>Copy the point on Endogenic processes on the left, then draw the diagram on the right: internal and external processes. Give it a title and label it clearly.</a:t>
+              <a:t>Let us copy The Big Bang Theory. The Big Bang theory explains the origin of the universe and of the Earth in the following stages. Copy the point on The beginning on the left, then draw the diagram on the right: a galaxy. Give it a title and label it clearly.</a:t>
             </a:r>
             <a:endParaRPr lang="en-US" dirty="0"/>
           </a:p>
@@ -3733,7 +3731,7 @@
           <a:p>
             <a:r>
               <a:rPr lang="en-US" dirty="0"/>
-              <a:t>We continue with Introduction to Geomorphology. On this slide we have Exogenic processes. Write each point on a new line, with the key term first, and explain it in your own words when we revise.</a:t>
+              <a:t>We continue with The Big Bang Theory. Copy the point on Formation of galaxies and stars: write the key term first, then its explanation.</a:t>
             </a:r>
             <a:endParaRPr lang="en-US" dirty="0"/>
           </a:p>
@@ -3821,7 +3819,7 @@
           <a:p>
             <a:r>
               <a:rPr lang="en-US" dirty="0"/>
-              <a:t>Let us copy The Big Bang Theory. The Big Bang theory is presented as follows. Copy the point on Beginning on the left, then draw the diagram on the right: a galaxy. Give it a title and label it clearly.</a:t>
+              <a:t>We continue with The Big Bang Theory. Copy the point on Formation of the Earth: write the key term first, then its explanation.</a:t>
             </a:r>
             <a:endParaRPr lang="en-US" dirty="0"/>
           </a:p>
@@ -3909,7 +3907,7 @@
           <a:p>
             <a:r>
               <a:rPr lang="en-US" dirty="0"/>
-              <a:t>We continue with The Big Bang Theory. On this slide we have Expansion, Formation of stars and planets and Birth of the Earth. Write each point on a new line, with the key term first, and explain it in your own words when we revise.</a:t>
+              <a:t>We continue with The Big Bang Theory. Copy the point on Evidence for the theory: write the key term first, then its explanation.</a:t>
             </a:r>
             <a:endParaRPr lang="en-US" dirty="0"/>
           </a:p>
@@ -3997,7 +3995,7 @@
           <a:p>
             <a:r>
               <a:rPr lang="en-US" dirty="0"/>
-              <a:t>Let us copy The Precambrian and the Palaeozoic. The first two eras have the following characteristics. Copy the point on Precambrian (4,600–541 million years ago) on the left, then draw the diagram on the right: the four eras. Give it a title and label it clearly.</a:t>
+              <a:t>Let us copy The Precambrian and the Palaeozoic. The first two eras have the following duration and characteristics. Copy the point on The divisions of time on the left, then draw the diagram on the right: the geologic time scale. Give it a title and label it clearly.</a:t>
             </a:r>
             <a:endParaRPr lang="en-US" dirty="0"/>
           </a:p>
@@ -4085,7 +4083,7 @@
           <a:p>
             <a:r>
               <a:rPr lang="en-US" dirty="0"/>
-              <a:t>We continue with The Precambrian and the Palaeozoic. On this slide we have Geology of the Precambrian. Write each point on a new line, with the key term first, and explain it in your own words when we revise.</a:t>
+              <a:t>Copy the point on Precambrian (4,600 to 541 million years ago) on the left, then draw the diagram on the right: stromatolites, the oldest fossils. Give it a title and label it clearly.</a:t>
             </a:r>
             <a:endParaRPr lang="en-US" dirty="0"/>
           </a:p>
@@ -4173,7 +4171,7 @@
           <a:p>
             <a:r>
               <a:rPr lang="en-US" dirty="0"/>
-              <a:t>Copy the point on Life in the Precambrian on the left, then draw the diagram on the right: stromatolites, early life. Give it a title and label it clearly.</a:t>
+              <a:t>Copy the point on Palaeozoic (541 to 252 million years ago) on the left, then draw the diagram on the right: a trilobite fossil. Give it a title and label it clearly.</a:t>
             </a:r>
             <a:endParaRPr lang="en-US" dirty="0"/>
           </a:p>
@@ -4261,7 +4259,7 @@
           <a:p>
             <a:r>
               <a:rPr lang="en-US" dirty="0"/>
-              <a:t>Copy the point on Palaeozoic ("ancient life", 541–252 million years ago) on the left, then draw the diagram on the right: a trilobite fossil. Give it a title and label it clearly.</a:t>
+              <a:t>Let us copy The Mesozoic and the Cenozoic. The last two eras have the following duration and characteristics. Copy the point on Mesozoic (252 to 66 million years ago) on the left, then draw the diagram on the right: a dinosaur skeleton. Give it a title and label it clearly.</a:t>
             </a:r>
             <a:endParaRPr lang="en-US" dirty="0"/>
           </a:p>
@@ -4349,7 +4347,7 @@
           <a:p>
             <a:r>
               <a:rPr lang="en-US" dirty="0"/>
-              <a:t>Let us copy The Mesozoic and the Cenozoic. The last two eras have the following characteristics. Copy the point on Mesozoic ("middle life", 252–66 million years ago) on the left, then draw the diagram on the right: a dinosaur. Give it a title and label it clearly.</a:t>
+              <a:t>We continue with The Mesozoic and the Cenozoic. Copy the point on Cenozoic (66 million years ago to today): write the key term first, then its explanation.</a:t>
             </a:r>
             <a:endParaRPr lang="en-US" dirty="0"/>
           </a:p>
@@ -4525,7 +4523,7 @@
           <a:p>
             <a:r>
               <a:rPr lang="en-US" dirty="0"/>
-              <a:t>We continue with The Mesozoic and the Cenozoic. On this slide we have Life in the Mesozoic. Write each point on a new line, with the key term first, and explain it in your own words when we revise. When you finish, we go to the next slide.</a:t>
+              <a:t>We continue with The Mesozoic and the Cenozoic. Copy the point on The place of man: write the key term first, then its explanation.</a:t>
             </a:r>
             <a:endParaRPr lang="en-US" dirty="0"/>
           </a:p>
@@ -4613,7 +4611,7 @@
           <a:p>
             <a:r>
               <a:rPr lang="en-US" dirty="0"/>
-              <a:t>We continue with The Mesozoic and the Cenozoic. On this slide we have Cenozoic ("recent life", 66 million years ago to today). Write each point on a new line, with the key term first, and explain it in your own words when we revise. When you finish, we go to the next slide.</a:t>
+              <a:t>Now let us check what you have understood. Question 1: Distinguish structural geomorphology from dynamic geomorphology. Answer in your exercise book.</a:t>
             </a:r>
             <a:endParaRPr lang="en-US" dirty="0"/>
           </a:p>
@@ -4701,7 +4699,7 @@
           <a:p>
             <a:r>
               <a:rPr lang="en-US" dirty="0"/>
-              <a:t>We continue with The Mesozoic and the Cenozoic. On this slide we have Life in the Cenozoic and Human history. Write each point on a new line, with the key term first, and explain it in your own words when we revise.</a:t>
+              <a:t>The expected answer is: structural geomorphology studies landforms made by internal structure and forces; dynamic geomorphology studies landforms made by external agents. If you got it right, well done.</a:t>
             </a:r>
             <a:endParaRPr lang="en-US" dirty="0"/>
           </a:p>
@@ -4789,7 +4787,7 @@
           <a:p>
             <a:r>
               <a:rPr lang="en-US" dirty="0"/>
-              <a:t>Now let us check what you have understood. Question 1: Distinguish structural geomorphology from dynamic geomorphology. Answer in your exercise book.</a:t>
+              <a:t>Now let us check what you have understood. Question 2: Give one geological and one biological event of the Mesozoic. Answer in your exercise book.</a:t>
             </a:r>
             <a:endParaRPr lang="en-US" dirty="0"/>
           </a:p>
@@ -4877,7 +4875,7 @@
           <a:p>
             <a:r>
               <a:rPr lang="en-US" dirty="0"/>
-              <a:t>The expected answer is: structural geomorphology studies landforms made by internal structure and forces; dynamic geomorphology studies landforms made by external agents. If you got it right, well done.</a:t>
+              <a:t>The expected answer is: pangaea broke up; dinosaurs dominated the land. If you got it right, well done.</a:t>
             </a:r>
             <a:endParaRPr lang="en-US" dirty="0"/>
           </a:p>
@@ -4965,7 +4963,7 @@
           <a:p>
             <a:r>
               <a:rPr lang="en-US" dirty="0"/>
-              <a:t>Now let us check what you have understood. Question 2: Give one geological and one biological event of the Mesozoic. Answer in your exercise book.</a:t>
+              <a:t>For those who need more practice, fill in the blanks in your exercise book. The answers are: number 1, ; number 4, 6; number 2, Precambrian; number 3, mammals.</a:t>
             </a:r>
             <a:endParaRPr lang="en-US" dirty="0"/>
           </a:p>
@@ -5053,7 +5051,7 @@
           <a:p>
             <a:r>
               <a:rPr lang="en-US" dirty="0"/>
-              <a:t>The expected answer is: pangaea broke up; dinosaurs dominated the land. If you got it right, well done.</a:t>
+              <a:t>For your homework: Name the three main layers of the Earth. We shall correct it at the beginning of our next lesson.</a:t>
             </a:r>
             <a:endParaRPr lang="en-US" dirty="0"/>
           </a:p>
@@ -5141,7 +5139,7 @@
           <a:p>
             <a:r>
               <a:rPr lang="en-US" dirty="0"/>
-              <a:t>For those who need more practice, fill in the blanks in your exercise book. The answers are: number 1, ; number 4, 6; number 2, Precambrian; number 3, mammals.</a:t>
+              <a:t>Our next lesson will be on Lesson 2: Internal Structure of the Earth. Thank you for your attention, and see you next time.</a:t>
             </a:r>
             <a:endParaRPr lang="en-US" dirty="0"/>
           </a:p>
@@ -5229,7 +5227,7 @@
           <a:p>
             <a:r>
               <a:rPr lang="en-US" dirty="0"/>
-              <a:t>For your homework: Name the three main layers of the Earth. We shall correct it at the beginning of our next lesson.</a:t>
+              <a:t>Let us play the bilingual game. I say a word in English, and you give me the French word. Then we do the reverse.</a:t>
             </a:r>
             <a:endParaRPr lang="en-US" dirty="0"/>
           </a:p>
@@ -5317,7 +5315,7 @@
           <a:p>
             <a:r>
               <a:rPr lang="en-US" dirty="0"/>
-              <a:t>Our next lesson will be on Lesson 2: Internal Structure of the Earth. Thank you for your attention, and see you next time.</a:t>
+              <a:t>I record this information in the official logbook of the class after the lesson.</a:t>
             </a:r>
             <a:endParaRPr lang="en-US" dirty="0"/>
           </a:p>
@@ -5493,7 +5491,7 @@
           <a:p>
             <a:r>
               <a:rPr lang="en-US" dirty="0"/>
-              <a:t>Let us play the bilingual game. I say a word in English, and you give me the French word. Then we do the reverse.</a:t>
+              <a:t>I complete the second page of the logbook: the matter taught, the evaluation, the homework and the attendance.</a:t>
             </a:r>
             <a:endParaRPr lang="en-US" dirty="0"/>
           </a:p>
@@ -5581,7 +5579,7 @@
           <a:p>
             <a:r>
               <a:rPr lang="en-US" dirty="0"/>
-              <a:t>I record this information in the official logbook of the class after the lesson.</a:t>
+              <a:t>This slide is for me, the teacher: it gives the timing of the lesson and what to do if the projector is not available.</a:t>
             </a:r>
             <a:endParaRPr lang="en-US" dirty="0"/>
           </a:p>
@@ -5669,7 +5667,7 @@
           <a:p>
             <a:r>
               <a:rPr lang="en-US" dirty="0"/>
-              <a:t>I complete the second page of the logbook: the matter taught, the evaluation, the homework and the attendance.</a:t>
+              <a:t>These are the references and picture credits used to prepare this lesson.</a:t>
             </a:r>
             <a:endParaRPr lang="en-US" dirty="0"/>
           </a:p>
@@ -5693,182 +5691,6 @@
             <a:fld id="{F7021451-1387-4CA6-816F-3879F97B5CBC}" type="slidenum">
               <a:rPr lang="en-US"/>
               <a:t>62</a:t>
-            </a:fld>
-            <a:endParaRPr lang="en-US"/>
-          </a:p>
-        </p:txBody>
-      </p:sp>
-    </p:spTree>
-    <p:extLst>
-      <p:ext uri="{BB962C8B-B14F-4D97-AF65-F5344CB8AC3E}">
-        <p14:creationId xmlns:p14="http://schemas.microsoft.com/office/powerpoint/2010/main" val="1024086991"/>
-      </p:ext>
-    </p:extLst>
-  </p:cSld>
-  <p:clrMapOvr>
-    <a:masterClrMapping/>
-  </p:clrMapOvr>
-</p:notes>
-</file>
-
-<file path=ppt/notesSlides/notesSlide63.xml><?xml version="1.0" encoding="utf-8"?>
-<p:notes xmlns:a="http://schemas.openxmlformats.org/drawingml/2006/main" xmlns:r="http://schemas.openxmlformats.org/officeDocument/2006/relationships" xmlns:p="http://schemas.openxmlformats.org/presentationml/2006/main">
-  <p:cSld>
-    <p:spTree>
-      <p:nvGrpSpPr>
-        <p:cNvPr id="1" name=""/>
-        <p:cNvGrpSpPr/>
-        <p:nvPr/>
-      </p:nvGrpSpPr>
-      <p:grpSpPr>
-        <a:xfrm>
-          <a:off x="0" y="0"/>
-          <a:ext cx="0" cy="0"/>
-          <a:chOff x="0" y="0"/>
-          <a:chExt cx="0" cy="0"/>
-        </a:xfrm>
-      </p:grpSpPr>
-      <p:sp>
-        <p:nvSpPr>
-          <p:cNvPr id="2" name="Slide Image Placeholder 1"/>
-          <p:cNvSpPr>
-            <a:spLocks noGrp="1" noRot="1" noChangeAspect="1"/>
-          </p:cNvSpPr>
-          <p:nvPr>
-            <p:ph type="sldImg"/>
-          </p:nvPr>
-        </p:nvSpPr>
-        <p:spPr/>
-      </p:sp>
-      <p:sp>
-        <p:nvSpPr>
-          <p:cNvPr id="3" name="Notes Placeholder 2"/>
-          <p:cNvSpPr>
-            <a:spLocks noGrp="1"/>
-          </p:cNvSpPr>
-          <p:nvPr>
-            <p:ph type="body" idx="1"/>
-          </p:nvPr>
-        </p:nvSpPr>
-        <p:spPr/>
-        <p:txBody>
-          <a:bodyPr/>
-          <a:lstStyle/>
-          <a:p>
-            <a:r>
-              <a:rPr lang="en-US" dirty="0"/>
-              <a:t>This slide is for me, the teacher: it gives the timing of the lesson and what to do if the projector is not available.</a:t>
-            </a:r>
-            <a:endParaRPr lang="en-US" dirty="0"/>
-          </a:p>
-        </p:txBody>
-      </p:sp>
-      <p:sp>
-        <p:nvSpPr>
-          <p:cNvPr id="4" name="Slide Number Placeholder 3"/>
-          <p:cNvSpPr>
-            <a:spLocks noGrp="1"/>
-          </p:cNvSpPr>
-          <p:nvPr>
-            <p:ph type="sldNum" sz="quarter" idx="10"/>
-          </p:nvPr>
-        </p:nvSpPr>
-        <p:spPr/>
-        <p:txBody>
-          <a:bodyPr/>
-          <a:lstStyle/>
-          <a:p>
-            <a:fld id="{F7021451-1387-4CA6-816F-3879F97B5CBC}" type="slidenum">
-              <a:rPr lang="en-US"/>
-              <a:t>63</a:t>
-            </a:fld>
-            <a:endParaRPr lang="en-US"/>
-          </a:p>
-        </p:txBody>
-      </p:sp>
-    </p:spTree>
-    <p:extLst>
-      <p:ext uri="{BB962C8B-B14F-4D97-AF65-F5344CB8AC3E}">
-        <p14:creationId xmlns:p14="http://schemas.microsoft.com/office/powerpoint/2010/main" val="1024086991"/>
-      </p:ext>
-    </p:extLst>
-  </p:cSld>
-  <p:clrMapOvr>
-    <a:masterClrMapping/>
-  </p:clrMapOvr>
-</p:notes>
-</file>
-
-<file path=ppt/notesSlides/notesSlide64.xml><?xml version="1.0" encoding="utf-8"?>
-<p:notes xmlns:a="http://schemas.openxmlformats.org/drawingml/2006/main" xmlns:r="http://schemas.openxmlformats.org/officeDocument/2006/relationships" xmlns:p="http://schemas.openxmlformats.org/presentationml/2006/main">
-  <p:cSld>
-    <p:spTree>
-      <p:nvGrpSpPr>
-        <p:cNvPr id="1" name=""/>
-        <p:cNvGrpSpPr/>
-        <p:nvPr/>
-      </p:nvGrpSpPr>
-      <p:grpSpPr>
-        <a:xfrm>
-          <a:off x="0" y="0"/>
-          <a:ext cx="0" cy="0"/>
-          <a:chOff x="0" y="0"/>
-          <a:chExt cx="0" cy="0"/>
-        </a:xfrm>
-      </p:grpSpPr>
-      <p:sp>
-        <p:nvSpPr>
-          <p:cNvPr id="2" name="Slide Image Placeholder 1"/>
-          <p:cNvSpPr>
-            <a:spLocks noGrp="1" noRot="1" noChangeAspect="1"/>
-          </p:cNvSpPr>
-          <p:nvPr>
-            <p:ph type="sldImg"/>
-          </p:nvPr>
-        </p:nvSpPr>
-        <p:spPr/>
-      </p:sp>
-      <p:sp>
-        <p:nvSpPr>
-          <p:cNvPr id="3" name="Notes Placeholder 2"/>
-          <p:cNvSpPr>
-            <a:spLocks noGrp="1"/>
-          </p:cNvSpPr>
-          <p:nvPr>
-            <p:ph type="body" idx="1"/>
-          </p:nvPr>
-        </p:nvSpPr>
-        <p:spPr/>
-        <p:txBody>
-          <a:bodyPr/>
-          <a:lstStyle/>
-          <a:p>
-            <a:r>
-              <a:rPr lang="en-US" dirty="0"/>
-              <a:t>These are the references and picture credits used to prepare this lesson.</a:t>
-            </a:r>
-            <a:endParaRPr lang="en-US" dirty="0"/>
-          </a:p>
-        </p:txBody>
-      </p:sp>
-      <p:sp>
-        <p:nvSpPr>
-          <p:cNvPr id="4" name="Slide Number Placeholder 3"/>
-          <p:cNvSpPr>
-            <a:spLocks noGrp="1"/>
-          </p:cNvSpPr>
-          <p:nvPr>
-            <p:ph type="sldNum" sz="quarter" idx="10"/>
-          </p:nvPr>
-        </p:nvSpPr>
-        <p:spPr/>
-        <p:txBody>
-          <a:bodyPr/>
-          <a:lstStyle/>
-          <a:p>
-            <a:fld id="{F7021451-1387-4CA6-816F-3879F97B5CBC}" type="slidenum">
-              <a:rPr lang="en-US"/>
-              <a:t>64</a:t>
             </a:fld>
             <a:endParaRPr lang="en-US"/>
           </a:p>
@@ -15625,7 +15447,7 @@
                 <a:ea typeface="Times New Roman" pitchFamily="34" charset="-122"/>
                 <a:cs typeface="Times New Roman" pitchFamily="34" charset="-120"/>
               </a:rPr>
-              <a:t>1. Introduction to Geomorphology</a:t>
+              <a:t>1. Meaning of Geomorphology</a:t>
             </a:r>
             <a:endParaRPr lang="en-US" sz="3600" dirty="0"/>
           </a:p>
@@ -15640,7 +15462,7 @@
         <p:spPr>
           <a:xfrm>
             <a:off x="365760" y="1783080"/>
-            <a:ext cx="4846320" cy="4617720"/>
+            <a:ext cx="6035040" cy="4617720"/>
           </a:xfrm>
           <a:prstGeom prst="rect">
             <a:avLst/>
@@ -15659,7 +15481,7 @@
               <a:buNone/>
             </a:pPr>
             <a:r>
-              <a:rPr lang="en-US" sz="3000" i="1" dirty="0">
+              <a:rPr lang="en-US" sz="3200" i="1" dirty="0">
                 <a:solidFill>
                   <a:srgbClr val="111111"/>
                 </a:solidFill>
@@ -15667,9 +15489,9 @@
                 <a:ea typeface="Times New Roman" pitchFamily="34" charset="-122"/>
                 <a:cs typeface="Times New Roman" pitchFamily="34" charset="-120"/>
               </a:rPr>
-              <a:t>The branches and processes of geomorphology are the following:</a:t>
-            </a:r>
-            <a:endParaRPr lang="en-US" sz="3000" dirty="0"/>
+              <a:t>Geomorphology is explained as follows:</a:t>
+            </a:r>
+            <a:endParaRPr lang="en-US" sz="3200" dirty="0"/>
           </a:p>
           <a:p>
             <a:pPr algn="l" indent="0" marL="0">
@@ -15679,7 +15501,7 @@
               <a:buNone/>
             </a:pPr>
             <a:r>
-              <a:rPr lang="en-US" sz="3000" b="1" dirty="0">
+              <a:rPr lang="en-US" sz="3200" b="1" dirty="0">
                 <a:solidFill>
                   <a:srgbClr val="111111"/>
                 </a:solidFill>
@@ -15687,7 +15509,7 @@
                 <a:ea typeface="Times New Roman" pitchFamily="34" charset="-122"/>
                 <a:cs typeface="Times New Roman" pitchFamily="34" charset="-120"/>
               </a:rPr>
-              <a:t>Structural geomorphology: </a:t>
+              <a:t>Geomorphology: </a:t>
             </a:r>
             <a:pPr algn="l" indent="0" marL="0">
               <a:spcAft>
@@ -15696,7 +15518,7 @@
               <a:buNone/>
             </a:pPr>
             <a:r>
-              <a:rPr lang="en-US" sz="3000" dirty="0">
+              <a:rPr lang="en-US" sz="3200" dirty="0">
                 <a:solidFill>
                   <a:srgbClr val="111111"/>
                 </a:solidFill>
@@ -15704,9 +15526,9 @@
                 <a:ea typeface="Times New Roman" pitchFamily="34" charset="-122"/>
                 <a:cs typeface="Times New Roman" pitchFamily="34" charset="-120"/>
               </a:rPr>
-              <a:t>It studies how internal structure, folds, faults and volcanoes shape landforms, like the Himalayas formed by plate collision.</a:t>
-            </a:r>
-            <a:endParaRPr lang="en-US" sz="3000" dirty="0"/>
+              <a:t>Geomorphology comes from Greek words meaning the study of the form of the Earth. It studies how landforms such as mountains, plains, valleys and coasts are formed and how they change over time.</a:t>
+            </a:r>
+            <a:endParaRPr lang="en-US" sz="3200" dirty="0"/>
           </a:p>
         </p:txBody>
       </p:sp>
@@ -15726,8 +15548,8 @@
         </p:blipFill>
         <p:spPr>
           <a:xfrm>
-            <a:off x="5349240" y="2617506"/>
-            <a:ext cx="6659575" cy="2601397"/>
+            <a:off x="6537960" y="2849678"/>
+            <a:ext cx="5470855" cy="2137053"/>
           </a:xfrm>
           <a:prstGeom prst="rect">
             <a:avLst/>
@@ -15742,8 +15564,8 @@
         </p:nvSpPr>
         <p:spPr>
           <a:xfrm>
-            <a:off x="5349240" y="6089904"/>
-            <a:ext cx="6659575" cy="347472"/>
+            <a:off x="6537960" y="6089904"/>
+            <a:ext cx="5470855" cy="347472"/>
           </a:xfrm>
           <a:prstGeom prst="rect">
             <a:avLst/>
@@ -15767,7 +15589,7 @@
                 <a:ea typeface="Times New Roman" pitchFamily="34" charset="-122"/>
                 <a:cs typeface="Times New Roman" pitchFamily="34" charset="-120"/>
               </a:rPr>
-              <a:t>Illustration: the two branches</a:t>
+              <a:t>Illustration: the branches of geomorphology</a:t>
             </a:r>
             <a:endParaRPr lang="en-US" sz="1600" dirty="0"/>
           </a:p>
@@ -16141,7 +15963,7 @@
         <p:spPr>
           <a:xfrm>
             <a:off x="0" y="658368"/>
-            <a:ext cx="5120640" cy="5833872"/>
+            <a:ext cx="2468880" cy="5833872"/>
           </a:xfrm>
           <a:prstGeom prst="rect">
             <a:avLst/>
@@ -16156,8 +15978,8 @@
         </p:nvSpPr>
         <p:spPr>
           <a:xfrm>
-            <a:off x="5349240" y="1005840"/>
-            <a:ext cx="6522415" cy="731520"/>
+            <a:off x="2697480" y="1005840"/>
+            <a:ext cx="9174175" cy="731520"/>
           </a:xfrm>
           <a:prstGeom prst="rect">
             <a:avLst/>
@@ -16183,7 +16005,7 @@
                 <a:ea typeface="Times New Roman" pitchFamily="34" charset="-122"/>
                 <a:cs typeface="Times New Roman" pitchFamily="34" charset="-120"/>
               </a:rPr>
-              <a:t>1. Introduction to Geomorphology</a:t>
+              <a:t>1. Meaning of Geomorphology</a:t>
             </a:r>
             <a:endParaRPr lang="en-US" sz="3600" dirty="0"/>
           </a:p>
@@ -16197,8 +16019,8 @@
         </p:nvSpPr>
         <p:spPr>
           <a:xfrm>
-            <a:off x="5349240" y="1783080"/>
-            <a:ext cx="6522415" cy="4663440"/>
+            <a:off x="2697480" y="1783080"/>
+            <a:ext cx="9174175" cy="4663440"/>
           </a:xfrm>
           <a:prstGeom prst="rect">
             <a:avLst/>
@@ -16225,7 +16047,7 @@
                 <a:ea typeface="Times New Roman" pitchFamily="34" charset="-122"/>
                 <a:cs typeface="Times New Roman" pitchFamily="34" charset="-120"/>
               </a:rPr>
-              <a:t>Dynamic geomorphology: </a:t>
+              <a:t>Its scope: </a:t>
             </a:r>
             <a:pPr algn="l" indent="0" marL="0">
               <a:spcAft>
@@ -16242,7 +16064,7 @@
                 <a:ea typeface="Times New Roman" pitchFamily="34" charset="-122"/>
                 <a:cs typeface="Times New Roman" pitchFamily="34" charset="-120"/>
               </a:rPr>
-              <a:t>It studies how rivers, wind, ice, gravity and weathering shape landforms, like the Grand Canyon carved by a river.</a:t>
+              <a:t>It studies the internal forces that build the relief, such as volcanism and folding, and the external forces that wear it down, such as rivers and weathering. To understand them, it starts with the origin and long history of the Earth.</a:t>
             </a:r>
             <a:endParaRPr lang="en-US" sz="4000" dirty="0"/>
           </a:p>
@@ -16395,7 +16217,7 @@
                 <a:ea typeface="Times New Roman" pitchFamily="34" charset="-122"/>
                 <a:cs typeface="Times New Roman" pitchFamily="34" charset="-120"/>
               </a:rPr>
-              <a:t>1. Introduction to Geomorphology</a:t>
+              <a:t>2. The Big Bang Theory</a:t>
             </a:r>
             <a:endParaRPr lang="en-US" sz="3600" dirty="0"/>
           </a:p>
@@ -16410,7 +16232,7 @@
         <p:spPr>
           <a:xfrm>
             <a:off x="365760" y="1783080"/>
-            <a:ext cx="4846320" cy="4617720"/>
+            <a:ext cx="6035040" cy="4617720"/>
           </a:xfrm>
           <a:prstGeom prst="rect">
             <a:avLst/>
@@ -16429,7 +16251,7 @@
               <a:buNone/>
             </a:pPr>
             <a:r>
-              <a:rPr lang="en-US" sz="3600" b="1" dirty="0">
+              <a:rPr lang="en-US" sz="2800" i="1" dirty="0">
                 <a:solidFill>
                   <a:srgbClr val="111111"/>
                 </a:solidFill>
@@ -16437,8 +16259,11 @@
                 <a:ea typeface="Times New Roman" pitchFamily="34" charset="-122"/>
                 <a:cs typeface="Times New Roman" pitchFamily="34" charset="-120"/>
               </a:rPr>
-              <a:t>Endogenic processes: </a:t>
-            </a:r>
+              <a:t>The Big Bang theory explains the origin of the universe and of the Earth in the following stages:</a:t>
+            </a:r>
+            <a:endParaRPr lang="en-US" sz="2800" dirty="0"/>
+          </a:p>
+          <a:p>
             <a:pPr algn="l" indent="0" marL="0">
               <a:spcAft>
                 <a:spcPts val="800"/>
@@ -16446,7 +16271,7 @@
               <a:buNone/>
             </a:pPr>
             <a:r>
-              <a:rPr lang="en-US" sz="3600" dirty="0">
+              <a:rPr lang="en-US" sz="2800" b="1" dirty="0">
                 <a:solidFill>
                   <a:srgbClr val="111111"/>
                 </a:solidFill>
@@ -16454,15 +16279,32 @@
                 <a:ea typeface="Times New Roman" pitchFamily="34" charset="-122"/>
                 <a:cs typeface="Times New Roman" pitchFamily="34" charset="-120"/>
               </a:rPr>
-              <a:t>They come from the heat inside the Earth and build up the land: plate movements, volcanism, folding and faulting.</a:t>
-            </a:r>
-            <a:endParaRPr lang="en-US" sz="3600" dirty="0"/>
+              <a:t>The beginning: </a:t>
+            </a:r>
+            <a:pPr algn="l" indent="0" marL="0">
+              <a:spcAft>
+                <a:spcPts val="800"/>
+              </a:spcAft>
+              <a:buNone/>
+            </a:pPr>
+            <a:r>
+              <a:rPr lang="en-US" sz="2800" dirty="0">
+                <a:solidFill>
+                  <a:srgbClr val="111111"/>
+                </a:solidFill>
+                <a:latin typeface="Times New Roman" pitchFamily="34" charset="0"/>
+                <a:ea typeface="Times New Roman" pitchFamily="34" charset="-122"/>
+                <a:cs typeface="Times New Roman" pitchFamily="34" charset="-120"/>
+              </a:rPr>
+              <a:t>About 13.8 billion years ago, all the matter and energy of the universe were concentrated in one extremely hot and dense point. This point expanded suddenly, creating space, time, matter and energy.</a:t>
+            </a:r>
+            <a:endParaRPr lang="en-US" sz="2800" dirty="0"/>
           </a:p>
         </p:txBody>
       </p:sp>
       <p:pic>
         <p:nvPicPr>
-          <p:cNvPr id="5" name="Image 0" descr="/home/claude/f4/img/v2/geo2_endo_exo.png">    </p:cNvPr>
+          <p:cNvPr id="5" name="Image 0" descr="/home/claude/f4/img/v2/lsa_galaxy.jpg">    </p:cNvPr>
           <p:cNvPicPr>
             <a:picLocks noChangeAspect="1"/>
           </p:cNvPicPr>
@@ -16476,8 +16318,8 @@
         </p:blipFill>
         <p:spPr>
           <a:xfrm>
-            <a:off x="5349240" y="2617506"/>
-            <a:ext cx="6659575" cy="2601397"/>
+            <a:off x="6537960" y="2400897"/>
+            <a:ext cx="5470855" cy="3034615"/>
           </a:xfrm>
           <a:prstGeom prst="rect">
             <a:avLst/>
@@ -16492,8 +16334,8 @@
         </p:nvSpPr>
         <p:spPr>
           <a:xfrm>
-            <a:off x="5349240" y="6089904"/>
-            <a:ext cx="6659575" cy="347472"/>
+            <a:off x="6537960" y="6089904"/>
+            <a:ext cx="5470855" cy="347472"/>
           </a:xfrm>
           <a:prstGeom prst="rect">
             <a:avLst/>
@@ -16517,7 +16359,7 @@
                 <a:ea typeface="Times New Roman" pitchFamily="34" charset="-122"/>
                 <a:cs typeface="Times New Roman" pitchFamily="34" charset="-120"/>
               </a:rPr>
-              <a:t>Illustration: internal and external processes</a:t>
+              <a:t>Illustration: a galaxy</a:t>
             </a:r>
             <a:endParaRPr lang="en-US" sz="1600" dirty="0"/>
           </a:p>
@@ -16652,7 +16494,7 @@
         <p:spPr>
           <a:xfrm>
             <a:off x="0" y="658368"/>
-            <a:ext cx="5120640" cy="5833872"/>
+            <a:ext cx="3840480" cy="5833872"/>
           </a:xfrm>
           <a:prstGeom prst="rect">
             <a:avLst/>
@@ -16667,8 +16509,8 @@
         </p:nvSpPr>
         <p:spPr>
           <a:xfrm>
-            <a:off x="5349240" y="1005840"/>
-            <a:ext cx="6522415" cy="731520"/>
+            <a:off x="4069080" y="1005840"/>
+            <a:ext cx="7802575" cy="731520"/>
           </a:xfrm>
           <a:prstGeom prst="rect">
             <a:avLst/>
@@ -16694,7 +16536,7 @@
                 <a:ea typeface="Times New Roman" pitchFamily="34" charset="-122"/>
                 <a:cs typeface="Times New Roman" pitchFamily="34" charset="-120"/>
               </a:rPr>
-              <a:t>1. Introduction to Geomorphology</a:t>
+              <a:t>2. The Big Bang Theory</a:t>
             </a:r>
             <a:endParaRPr lang="en-US" sz="3600" dirty="0"/>
           </a:p>
@@ -16708,8 +16550,8 @@
         </p:nvSpPr>
         <p:spPr>
           <a:xfrm>
-            <a:off x="5349240" y="1783080"/>
-            <a:ext cx="6522415" cy="4663440"/>
+            <a:off x="4069080" y="1783080"/>
+            <a:ext cx="7802575" cy="4663440"/>
           </a:xfrm>
           <a:prstGeom prst="rect">
             <a:avLst/>
@@ -16736,7 +16578,7 @@
                 <a:ea typeface="Times New Roman" pitchFamily="34" charset="-122"/>
                 <a:cs typeface="Times New Roman" pitchFamily="34" charset="-120"/>
               </a:rPr>
-              <a:t>Exogenic processes: </a:t>
+              <a:t>Formation of galaxies and stars: </a:t>
             </a:r>
             <a:pPr algn="l" indent="0" marL="0">
               <a:spcAft>
@@ -16753,7 +16595,7 @@
                 <a:ea typeface="Times New Roman" pitchFamily="34" charset="-122"/>
                 <a:cs typeface="Times New Roman" pitchFamily="34" charset="-120"/>
               </a:rPr>
-              <a:t>They are powered by the Sun and wear down the land: weathering, erosion, deposition and glaciation.</a:t>
+              <a:t>As the universe expanded, it cooled and matter gathered under gravity into clouds of gas. These clouds formed galaxies and stars, in which heavier elements were made.</a:t>
             </a:r>
             <a:endParaRPr lang="en-US" sz="4000" dirty="0"/>
           </a:p>
@@ -16871,129 +16713,9 @@
           </a:p>
         </p:txBody>
       </p:sp>
-      <p:sp>
-        <p:nvSpPr>
-          <p:cNvPr id="3" name="Text 1"/>
-          <p:cNvSpPr/>
-          <p:nvPr/>
-        </p:nvSpPr>
-        <p:spPr>
-          <a:xfrm>
-            <a:off x="365760" y="1005840"/>
-            <a:ext cx="11460175" cy="731520"/>
-          </a:xfrm>
-          <a:prstGeom prst="rect">
-            <a:avLst/>
-          </a:prstGeom>
-          <a:noFill/>
-          <a:ln/>
-        </p:spPr>
-        <p:txBody>
-          <a:bodyPr wrap="square" lIns="0" tIns="0" rIns="0" bIns="0" rtlCol="0" anchor="ctr">
-            <a:normAutofit/>
-          </a:bodyPr>
-          <a:lstStyle/>
-          <a:p>
-            <a:pPr algn="ctr" indent="0" marL="0">
-              <a:buNone/>
-            </a:pPr>
-            <a:r>
-              <a:rPr lang="en-US" sz="3600" b="1" dirty="0">
-                <a:solidFill>
-                  <a:srgbClr val="990011"/>
-                </a:solidFill>
-                <a:latin typeface="Times New Roman" pitchFamily="34" charset="0"/>
-                <a:ea typeface="Times New Roman" pitchFamily="34" charset="-122"/>
-                <a:cs typeface="Times New Roman" pitchFamily="34" charset="-120"/>
-              </a:rPr>
-              <a:t>2. The Big Bang Theory</a:t>
-            </a:r>
-            <a:endParaRPr lang="en-US" sz="3600" dirty="0"/>
-          </a:p>
-        </p:txBody>
-      </p:sp>
-      <p:sp>
-        <p:nvSpPr>
-          <p:cNvPr id="4" name="Text 2"/>
-          <p:cNvSpPr/>
-          <p:nvPr/>
-        </p:nvSpPr>
-        <p:spPr>
-          <a:xfrm>
-            <a:off x="365760" y="1783080"/>
-            <a:ext cx="4846320" cy="4617720"/>
-          </a:xfrm>
-          <a:prstGeom prst="rect">
-            <a:avLst/>
-          </a:prstGeom>
-          <a:noFill/>
-          <a:ln/>
-        </p:spPr>
-        <p:txBody>
-          <a:bodyPr wrap="square" lIns="0" tIns="0" rIns="0" bIns="0" rtlCol="0" anchor="t"/>
-          <a:lstStyle/>
-          <a:p>
-            <a:pPr algn="l" indent="0" marL="0">
-              <a:spcAft>
-                <a:spcPts val="800"/>
-              </a:spcAft>
-              <a:buNone/>
-            </a:pPr>
-            <a:r>
-              <a:rPr lang="en-US" sz="3600" i="1" dirty="0">
-                <a:solidFill>
-                  <a:srgbClr val="111111"/>
-                </a:solidFill>
-                <a:latin typeface="Times New Roman" pitchFamily="34" charset="0"/>
-                <a:ea typeface="Times New Roman" pitchFamily="34" charset="-122"/>
-                <a:cs typeface="Times New Roman" pitchFamily="34" charset="-120"/>
-              </a:rPr>
-              <a:t>The Big Bang theory is presented as follows:</a:t>
-            </a:r>
-            <a:endParaRPr lang="en-US" sz="3600" dirty="0"/>
-          </a:p>
-          <a:p>
-            <a:pPr algn="l" indent="0" marL="0">
-              <a:spcAft>
-                <a:spcPts val="800"/>
-              </a:spcAft>
-              <a:buNone/>
-            </a:pPr>
-            <a:r>
-              <a:rPr lang="en-US" sz="3600" b="1" dirty="0">
-                <a:solidFill>
-                  <a:srgbClr val="111111"/>
-                </a:solidFill>
-                <a:latin typeface="Times New Roman" pitchFamily="34" charset="0"/>
-                <a:ea typeface="Times New Roman" pitchFamily="34" charset="-122"/>
-                <a:cs typeface="Times New Roman" pitchFamily="34" charset="-120"/>
-              </a:rPr>
-              <a:t>Beginning: </a:t>
-            </a:r>
-            <a:pPr algn="l" indent="0" marL="0">
-              <a:spcAft>
-                <a:spcPts val="800"/>
-              </a:spcAft>
-              <a:buNone/>
-            </a:pPr>
-            <a:r>
-              <a:rPr lang="en-US" sz="3600" dirty="0">
-                <a:solidFill>
-                  <a:srgbClr val="111111"/>
-                </a:solidFill>
-                <a:latin typeface="Times New Roman" pitchFamily="34" charset="0"/>
-                <a:ea typeface="Times New Roman" pitchFamily="34" charset="-122"/>
-                <a:cs typeface="Times New Roman" pitchFamily="34" charset="-120"/>
-              </a:rPr>
-              <a:t>About 13.8 billion years ago, all the universe was concentrated in one extremely hot and dense point.</a:t>
-            </a:r>
-            <a:endParaRPr lang="en-US" sz="3600" dirty="0"/>
-          </a:p>
-        </p:txBody>
-      </p:sp>
       <p:pic>
         <p:nvPicPr>
-          <p:cNvPr id="5" name="Image 0" descr="/home/claude/f4/img/v2/lsa_galaxy.jpg">    </p:cNvPr>
+          <p:cNvPr id="3" name="Image 0" descr="/home/claude/f4/img/minesec_sheet.png">    </p:cNvPr>
           <p:cNvPicPr>
             <a:picLocks noChangeAspect="1"/>
           </p:cNvPicPr>
@@ -17007,8 +16729,8 @@
         </p:blipFill>
         <p:spPr>
           <a:xfrm>
-            <a:off x="5349240" y="2071212"/>
-            <a:ext cx="6659575" cy="3693983"/>
+            <a:off x="0" y="658368"/>
+            <a:ext cx="3840480" cy="5833872"/>
           </a:xfrm>
           <a:prstGeom prst="rect">
             <a:avLst/>
@@ -17017,14 +16739,14 @@
       </p:pic>
       <p:sp>
         <p:nvSpPr>
-          <p:cNvPr id="6" name="Text 3"/>
+          <p:cNvPr id="4" name="Text 1"/>
           <p:cNvSpPr/>
           <p:nvPr/>
         </p:nvSpPr>
         <p:spPr>
           <a:xfrm>
-            <a:off x="5349240" y="6089904"/>
-            <a:ext cx="6659575" cy="347472"/>
+            <a:off x="4069080" y="1005840"/>
+            <a:ext cx="7802575" cy="731520"/>
           </a:xfrm>
           <a:prstGeom prst="rect">
             <a:avLst/>
@@ -17033,24 +16755,85 @@
           <a:ln/>
         </p:spPr>
         <p:txBody>
-          <a:bodyPr wrap="square" lIns="0" tIns="0" rIns="0" bIns="0" rtlCol="0" anchor="ctr"/>
+          <a:bodyPr wrap="square" lIns="0" tIns="0" rIns="0" bIns="0" rtlCol="0" anchor="ctr">
+            <a:normAutofit/>
+          </a:bodyPr>
           <a:lstStyle/>
           <a:p>
             <a:pPr algn="ctr" indent="0" marL="0">
               <a:buNone/>
             </a:pPr>
             <a:r>
-              <a:rPr lang="en-US" sz="1600" i="1" dirty="0">
-                <a:solidFill>
-                  <a:srgbClr val="555555"/>
+              <a:rPr lang="en-US" sz="3600" b="1" dirty="0">
+                <a:solidFill>
+                  <a:srgbClr val="990011"/>
                 </a:solidFill>
                 <a:latin typeface="Times New Roman" pitchFamily="34" charset="0"/>
                 <a:ea typeface="Times New Roman" pitchFamily="34" charset="-122"/>
                 <a:cs typeface="Times New Roman" pitchFamily="34" charset="-120"/>
               </a:rPr>
-              <a:t>Illustration: a galaxy</a:t>
-            </a:r>
-            <a:endParaRPr lang="en-US" sz="1600" dirty="0"/>
+              <a:t>2. The Big Bang Theory</a:t>
+            </a:r>
+            <a:endParaRPr lang="en-US" sz="3600" dirty="0"/>
+          </a:p>
+        </p:txBody>
+      </p:sp>
+      <p:sp>
+        <p:nvSpPr>
+          <p:cNvPr id="5" name="Text 2"/>
+          <p:cNvSpPr/>
+          <p:nvPr/>
+        </p:nvSpPr>
+        <p:spPr>
+          <a:xfrm>
+            <a:off x="4069080" y="1783080"/>
+            <a:ext cx="7802575" cy="4663440"/>
+          </a:xfrm>
+          <a:prstGeom prst="rect">
+            <a:avLst/>
+          </a:prstGeom>
+          <a:noFill/>
+          <a:ln/>
+        </p:spPr>
+        <p:txBody>
+          <a:bodyPr wrap="square" lIns="0" tIns="0" rIns="0" bIns="0" rtlCol="0" anchor="t"/>
+          <a:lstStyle/>
+          <a:p>
+            <a:pPr algn="l" indent="0" marL="0">
+              <a:spcAft>
+                <a:spcPts val="800"/>
+              </a:spcAft>
+              <a:buNone/>
+            </a:pPr>
+            <a:r>
+              <a:rPr lang="en-US" sz="4000" b="1" dirty="0">
+                <a:solidFill>
+                  <a:srgbClr val="111111"/>
+                </a:solidFill>
+                <a:latin typeface="Times New Roman" pitchFamily="34" charset="0"/>
+                <a:ea typeface="Times New Roman" pitchFamily="34" charset="-122"/>
+                <a:cs typeface="Times New Roman" pitchFamily="34" charset="-120"/>
+              </a:rPr>
+              <a:t>Formation of the Earth: </a:t>
+            </a:r>
+            <a:pPr algn="l" indent="0" marL="0">
+              <a:spcAft>
+                <a:spcPts val="800"/>
+              </a:spcAft>
+              <a:buNone/>
+            </a:pPr>
+            <a:r>
+              <a:rPr lang="en-US" sz="4000" dirty="0">
+                <a:solidFill>
+                  <a:srgbClr val="111111"/>
+                </a:solidFill>
+                <a:latin typeface="Times New Roman" pitchFamily="34" charset="0"/>
+                <a:ea typeface="Times New Roman" pitchFamily="34" charset="-122"/>
+                <a:cs typeface="Times New Roman" pitchFamily="34" charset="-120"/>
+              </a:rPr>
+              <a:t>About 4.6 billion years ago, a cloud of gas and dust collapsed to form the Sun and the planets. The Earth grew by the collision of rocky fragments, then cooled and separated into layers.</a:t>
+            </a:r>
+            <a:endParaRPr lang="en-US" sz="4000" dirty="0"/>
           </a:p>
         </p:txBody>
       </p:sp>
@@ -17183,7 +16966,7 @@
         <p:spPr>
           <a:xfrm>
             <a:off x="0" y="658368"/>
-            <a:ext cx="1463040" cy="5833872"/>
+            <a:ext cx="2468880" cy="5833872"/>
           </a:xfrm>
           <a:prstGeom prst="rect">
             <a:avLst/>
@@ -17198,8 +16981,8 @@
         </p:nvSpPr>
         <p:spPr>
           <a:xfrm>
-            <a:off x="1691640" y="1005840"/>
-            <a:ext cx="10180015" cy="731520"/>
+            <a:off x="2697480" y="1005840"/>
+            <a:ext cx="9174175" cy="731520"/>
           </a:xfrm>
           <a:prstGeom prst="rect">
             <a:avLst/>
@@ -17239,8 +17022,8 @@
         </p:nvSpPr>
         <p:spPr>
           <a:xfrm>
-            <a:off x="1691640" y="1783080"/>
-            <a:ext cx="10180015" cy="4663440"/>
+            <a:off x="2697480" y="1783080"/>
+            <a:ext cx="9174175" cy="4663440"/>
           </a:xfrm>
           <a:prstGeom prst="rect">
             <a:avLst/>
@@ -17267,7 +17050,7 @@
                 <a:ea typeface="Times New Roman" pitchFamily="34" charset="-122"/>
                 <a:cs typeface="Times New Roman" pitchFamily="34" charset="-120"/>
               </a:rPr>
-              <a:t>Expansion: </a:t>
+              <a:t>Evidence for the theory: </a:t>
             </a:r>
             <a:pPr algn="l" indent="0" marL="0">
               <a:spcAft>
@@ -17284,81 +17067,7 @@
                 <a:ea typeface="Times New Roman" pitchFamily="34" charset="-122"/>
                 <a:cs typeface="Times New Roman" pitchFamily="34" charset="-120"/>
               </a:rPr>
-              <a:t>This point expanded suddenly, creating matter, energy, space and time.</a:t>
-            </a:r>
-            <a:endParaRPr lang="en-US" sz="4000" dirty="0"/>
-          </a:p>
-          <a:p>
-            <a:pPr algn="l" indent="0" marL="0">
-              <a:spcAft>
-                <a:spcPts val="800"/>
-              </a:spcAft>
-              <a:buNone/>
-            </a:pPr>
-            <a:r>
-              <a:rPr lang="en-US" sz="4000" b="1" dirty="0">
-                <a:solidFill>
-                  <a:srgbClr val="111111"/>
-                </a:solidFill>
-                <a:latin typeface="Times New Roman" pitchFamily="34" charset="0"/>
-                <a:ea typeface="Times New Roman" pitchFamily="34" charset="-122"/>
-                <a:cs typeface="Times New Roman" pitchFamily="34" charset="-120"/>
-              </a:rPr>
-              <a:t>Formation of stars and planets: </a:t>
-            </a:r>
-            <a:pPr algn="l" indent="0" marL="0">
-              <a:spcAft>
-                <a:spcPts val="800"/>
-              </a:spcAft>
-              <a:buNone/>
-            </a:pPr>
-            <a:r>
-              <a:rPr lang="en-US" sz="4000" dirty="0">
-                <a:solidFill>
-                  <a:srgbClr val="111111"/>
-                </a:solidFill>
-                <a:latin typeface="Times New Roman" pitchFamily="34" charset="0"/>
-                <a:ea typeface="Times New Roman" pitchFamily="34" charset="-122"/>
-                <a:cs typeface="Times New Roman" pitchFamily="34" charset="-120"/>
-              </a:rPr>
-              <a:t>Over billions of years, matter cooled and gathered into galaxies, stars and planets.</a:t>
-            </a:r>
-            <a:endParaRPr lang="en-US" sz="4000" dirty="0"/>
-          </a:p>
-          <a:p>
-            <a:pPr algn="l" indent="0" marL="0">
-              <a:spcAft>
-                <a:spcPts val="800"/>
-              </a:spcAft>
-              <a:buNone/>
-            </a:pPr>
-            <a:r>
-              <a:rPr lang="en-US" sz="4000" b="1" dirty="0">
-                <a:solidFill>
-                  <a:srgbClr val="111111"/>
-                </a:solidFill>
-                <a:latin typeface="Times New Roman" pitchFamily="34" charset="0"/>
-                <a:ea typeface="Times New Roman" pitchFamily="34" charset="-122"/>
-                <a:cs typeface="Times New Roman" pitchFamily="34" charset="-120"/>
-              </a:rPr>
-              <a:t>Birth of the Earth: </a:t>
-            </a:r>
-            <a:pPr algn="l" indent="0" marL="0">
-              <a:spcAft>
-                <a:spcPts val="800"/>
-              </a:spcAft>
-              <a:buNone/>
-            </a:pPr>
-            <a:r>
-              <a:rPr lang="en-US" sz="4000" dirty="0">
-                <a:solidFill>
-                  <a:srgbClr val="111111"/>
-                </a:solidFill>
-                <a:latin typeface="Times New Roman" pitchFamily="34" charset="0"/>
-                <a:ea typeface="Times New Roman" pitchFamily="34" charset="-122"/>
-                <a:cs typeface="Times New Roman" pitchFamily="34" charset="-120"/>
-              </a:rPr>
-              <a:t>The Earth formed about 4.6 billion years ago.</a:t>
+              <a:t>Galaxies are still moving away from each other, which shows that the universe is expanding. Scientists also detect a weak radiation left over from the early hot universe, called the cosmic microwave background.</a:t>
             </a:r>
             <a:endParaRPr lang="en-US" sz="4000" dirty="0"/>
           </a:p>
@@ -17526,7 +17235,7 @@
         <p:spPr>
           <a:xfrm>
             <a:off x="365760" y="1737360"/>
-            <a:ext cx="5120640" cy="457200"/>
+            <a:ext cx="6035040" cy="457200"/>
           </a:xfrm>
           <a:prstGeom prst="rect">
             <a:avLst/>
@@ -17567,7 +17276,7 @@
         <p:spPr>
           <a:xfrm>
             <a:off x="365760" y="2240280"/>
-            <a:ext cx="4846320" cy="4160520"/>
+            <a:ext cx="6035040" cy="4160520"/>
           </a:xfrm>
           <a:prstGeom prst="rect">
             <a:avLst/>
@@ -17586,7 +17295,7 @@
               <a:buNone/>
             </a:pPr>
             <a:r>
-              <a:rPr lang="en-US" sz="3400" i="1" dirty="0">
+              <a:rPr lang="en-US" sz="2800" i="1" dirty="0">
                 <a:solidFill>
                   <a:srgbClr val="111111"/>
                 </a:solidFill>
@@ -17594,9 +17303,9 @@
                 <a:ea typeface="Times New Roman" pitchFamily="34" charset="-122"/>
                 <a:cs typeface="Times New Roman" pitchFamily="34" charset="-120"/>
               </a:rPr>
-              <a:t>The first two eras have the following characteristics:</a:t>
-            </a:r>
-            <a:endParaRPr lang="en-US" sz="3400" dirty="0"/>
+              <a:t>The first two eras have the following duration and characteristics:</a:t>
+            </a:r>
+            <a:endParaRPr lang="en-US" sz="2800" dirty="0"/>
           </a:p>
           <a:p>
             <a:pPr algn="l" indent="0" marL="0">
@@ -17606,7 +17315,7 @@
               <a:buNone/>
             </a:pPr>
             <a:r>
-              <a:rPr lang="en-US" sz="3400" b="1" dirty="0">
+              <a:rPr lang="en-US" sz="2800" b="1" dirty="0">
                 <a:solidFill>
                   <a:srgbClr val="111111"/>
                 </a:solidFill>
@@ -17614,7 +17323,7 @@
                 <a:ea typeface="Times New Roman" pitchFamily="34" charset="-122"/>
                 <a:cs typeface="Times New Roman" pitchFamily="34" charset="-120"/>
               </a:rPr>
-              <a:t>Precambrian (4,600–541 million years ago): </a:t>
+              <a:t>The divisions of time: </a:t>
             </a:r>
             <a:pPr algn="l" indent="0" marL="0">
               <a:spcAft>
@@ -17623,7 +17332,7 @@
               <a:buNone/>
             </a:pPr>
             <a:r>
-              <a:rPr lang="en-US" sz="3400" dirty="0">
+              <a:rPr lang="en-US" sz="2800" dirty="0">
                 <a:solidFill>
                   <a:srgbClr val="111111"/>
                 </a:solidFill>
@@ -17631,9 +17340,9 @@
                 <a:ea typeface="Times New Roman" pitchFamily="34" charset="-122"/>
                 <a:cs typeface="Times New Roman" pitchFamily="34" charset="-120"/>
               </a:rPr>
-              <a:t>It covers about 88 % of the history of the Earth.</a:t>
-            </a:r>
-            <a:endParaRPr lang="en-US" sz="3400" dirty="0"/>
+              <a:t>Geologists divide the 4.6 billion years of Earth history into eons, eras, periods and epochs. The four main eras are the Precambrian, the Palaeozoic, the Mesozoic and the Cenozoic.</a:t>
+            </a:r>
+            <a:endParaRPr lang="en-US" sz="2800" dirty="0"/>
           </a:p>
         </p:txBody>
       </p:sp>
@@ -17653,8 +17362,8 @@
         </p:blipFill>
         <p:spPr>
           <a:xfrm>
-            <a:off x="5349240" y="2617506"/>
-            <a:ext cx="6659575" cy="2601397"/>
+            <a:off x="6537960" y="2849678"/>
+            <a:ext cx="5470855" cy="2137053"/>
           </a:xfrm>
           <a:prstGeom prst="rect">
             <a:avLst/>
@@ -17669,8 +17378,8 @@
         </p:nvSpPr>
         <p:spPr>
           <a:xfrm>
-            <a:off x="5349240" y="6089904"/>
-            <a:ext cx="6659575" cy="347472"/>
+            <a:off x="6537960" y="6089904"/>
+            <a:ext cx="5470855" cy="347472"/>
           </a:xfrm>
           <a:prstGeom prst="rect">
             <a:avLst/>
@@ -17694,7 +17403,7 @@
                 <a:ea typeface="Times New Roman" pitchFamily="34" charset="-122"/>
                 <a:cs typeface="Times New Roman" pitchFamily="34" charset="-120"/>
               </a:rPr>
-              <a:t>Illustration: the four eras</a:t>
+              <a:t>Illustration: the geologic time scale</a:t>
             </a:r>
             <a:endParaRPr lang="en-US" sz="1600" dirty="0"/>
           </a:p>
@@ -17812,9 +17521,150 @@
           </a:p>
         </p:txBody>
       </p:sp>
+      <p:sp>
+        <p:nvSpPr>
+          <p:cNvPr id="3" name="Text 1"/>
+          <p:cNvSpPr/>
+          <p:nvPr/>
+        </p:nvSpPr>
+        <p:spPr>
+          <a:xfrm>
+            <a:off x="365760" y="1005840"/>
+            <a:ext cx="11460175" cy="731520"/>
+          </a:xfrm>
+          <a:prstGeom prst="rect">
+            <a:avLst/>
+          </a:prstGeom>
+          <a:noFill/>
+          <a:ln/>
+        </p:spPr>
+        <p:txBody>
+          <a:bodyPr wrap="square" lIns="0" tIns="0" rIns="0" bIns="0" rtlCol="0" anchor="ctr">
+            <a:normAutofit/>
+          </a:bodyPr>
+          <a:lstStyle/>
+          <a:p>
+            <a:pPr algn="ctr" indent="0" marL="0">
+              <a:buNone/>
+            </a:pPr>
+            <a:r>
+              <a:rPr lang="en-US" sz="3600" b="1" dirty="0">
+                <a:solidFill>
+                  <a:srgbClr val="990011"/>
+                </a:solidFill>
+                <a:latin typeface="Times New Roman" pitchFamily="34" charset="0"/>
+                <a:ea typeface="Times New Roman" pitchFamily="34" charset="-122"/>
+                <a:cs typeface="Times New Roman" pitchFamily="34" charset="-120"/>
+              </a:rPr>
+              <a:t>3. The Geologic Time Scale</a:t>
+            </a:r>
+            <a:endParaRPr lang="en-US" sz="3600" dirty="0"/>
+          </a:p>
+        </p:txBody>
+      </p:sp>
+      <p:sp>
+        <p:nvSpPr>
+          <p:cNvPr id="4" name="Text 2"/>
+          <p:cNvSpPr/>
+          <p:nvPr/>
+        </p:nvSpPr>
+        <p:spPr>
+          <a:xfrm>
+            <a:off x="365760" y="1737360"/>
+            <a:ext cx="6035040" cy="457200"/>
+          </a:xfrm>
+          <a:prstGeom prst="rect">
+            <a:avLst/>
+          </a:prstGeom>
+          <a:noFill/>
+          <a:ln/>
+        </p:spPr>
+        <p:txBody>
+          <a:bodyPr wrap="square" lIns="0" tIns="0" rIns="0" bIns="0" rtlCol="0" anchor="ctr">
+            <a:normAutofit/>
+          </a:bodyPr>
+          <a:lstStyle/>
+          <a:p>
+            <a:pPr algn="l" indent="0" marL="0">
+              <a:buNone/>
+            </a:pPr>
+            <a:r>
+              <a:rPr lang="en-US" sz="3000" b="1" dirty="0">
+                <a:solidFill>
+                  <a:srgbClr val="990011"/>
+                </a:solidFill>
+                <a:latin typeface="Times New Roman" pitchFamily="34" charset="0"/>
+                <a:ea typeface="Times New Roman" pitchFamily="34" charset="-122"/>
+                <a:cs typeface="Times New Roman" pitchFamily="34" charset="-120"/>
+              </a:rPr>
+              <a:t>A) The Precambrian and the Palaeozoic</a:t>
+            </a:r>
+            <a:endParaRPr lang="en-US" sz="3000" dirty="0"/>
+          </a:p>
+        </p:txBody>
+      </p:sp>
+      <p:sp>
+        <p:nvSpPr>
+          <p:cNvPr id="5" name="Text 3"/>
+          <p:cNvSpPr/>
+          <p:nvPr/>
+        </p:nvSpPr>
+        <p:spPr>
+          <a:xfrm>
+            <a:off x="365760" y="2240280"/>
+            <a:ext cx="6035040" cy="4160520"/>
+          </a:xfrm>
+          <a:prstGeom prst="rect">
+            <a:avLst/>
+          </a:prstGeom>
+          <a:noFill/>
+          <a:ln/>
+        </p:spPr>
+        <p:txBody>
+          <a:bodyPr wrap="square" lIns="0" tIns="0" rIns="0" bIns="0" rtlCol="0" anchor="t"/>
+          <a:lstStyle/>
+          <a:p>
+            <a:pPr algn="l" indent="0" marL="0">
+              <a:spcAft>
+                <a:spcPts val="800"/>
+              </a:spcAft>
+              <a:buNone/>
+            </a:pPr>
+            <a:r>
+              <a:rPr lang="en-US" sz="2600" b="1" dirty="0">
+                <a:solidFill>
+                  <a:srgbClr val="111111"/>
+                </a:solidFill>
+                <a:latin typeface="Times New Roman" pitchFamily="34" charset="0"/>
+                <a:ea typeface="Times New Roman" pitchFamily="34" charset="-122"/>
+                <a:cs typeface="Times New Roman" pitchFamily="34" charset="-120"/>
+              </a:rPr>
+              <a:t>Precambrian (4,600 to 541 million years ago): </a:t>
+            </a:r>
+            <a:pPr algn="l" indent="0" marL="0">
+              <a:spcAft>
+                <a:spcPts val="800"/>
+              </a:spcAft>
+              <a:buNone/>
+            </a:pPr>
+            <a:r>
+              <a:rPr lang="en-US" sz="2600" dirty="0">
+                <a:solidFill>
+                  <a:srgbClr val="111111"/>
+                </a:solidFill>
+                <a:latin typeface="Times New Roman" pitchFamily="34" charset="0"/>
+                <a:ea typeface="Times New Roman" pitchFamily="34" charset="-122"/>
+                <a:cs typeface="Times New Roman" pitchFamily="34" charset="-120"/>
+              </a:rPr>
+              <a:t>It covers about 88 % of the history of the Earth, during which the crust, the first continents, the oceans and the atmosphere formed. Only simple, single-celled life such as bacteria and algae existed, and the old rocks of the African Shield, including those of North Cameroon, date from this era.</a:t>
+            </a:r>
+            <a:endParaRPr lang="en-US" sz="2600" dirty="0"/>
+          </a:p>
+        </p:txBody>
+      </p:sp>
       <p:pic>
         <p:nvPicPr>
-          <p:cNvPr id="3" name="Image 0" descr="/home/claude/f4/img/minesec_sheet.png">    </p:cNvPr>
+          <p:cNvPr id="6" name="Image 0" descr="/home/claude/f4/img/v2/lsa_stromatolite.jpg">    </p:cNvPr>
           <p:cNvPicPr>
             <a:picLocks noChangeAspect="1"/>
           </p:cNvPicPr>
@@ -17828,8 +17678,8 @@
         </p:blipFill>
         <p:spPr>
           <a:xfrm>
-            <a:off x="0" y="658368"/>
-            <a:ext cx="3840480" cy="5833872"/>
+            <a:off x="6537960" y="2400897"/>
+            <a:ext cx="5470855" cy="3034615"/>
           </a:xfrm>
           <a:prstGeom prst="rect">
             <a:avLst/>
@@ -17838,14 +17688,14 @@
       </p:pic>
       <p:sp>
         <p:nvSpPr>
-          <p:cNvPr id="4" name="Text 1"/>
+          <p:cNvPr id="7" name="Text 4"/>
           <p:cNvSpPr/>
           <p:nvPr/>
         </p:nvSpPr>
         <p:spPr>
           <a:xfrm>
-            <a:off x="4069080" y="1005840"/>
-            <a:ext cx="7802575" cy="731520"/>
+            <a:off x="6537960" y="6089904"/>
+            <a:ext cx="5470855" cy="347472"/>
           </a:xfrm>
           <a:prstGeom prst="rect">
             <a:avLst/>
@@ -17854,124 +17704,24 @@
           <a:ln/>
         </p:spPr>
         <p:txBody>
-          <a:bodyPr wrap="square" lIns="0" tIns="0" rIns="0" bIns="0" rtlCol="0" anchor="ctr">
-            <a:normAutofit/>
-          </a:bodyPr>
+          <a:bodyPr wrap="square" lIns="0" tIns="0" rIns="0" bIns="0" rtlCol="0" anchor="ctr"/>
           <a:lstStyle/>
           <a:p>
             <a:pPr algn="ctr" indent="0" marL="0">
               <a:buNone/>
             </a:pPr>
             <a:r>
-              <a:rPr lang="en-US" sz="3600" b="1" dirty="0">
-                <a:solidFill>
-                  <a:srgbClr val="990011"/>
+              <a:rPr lang="en-US" sz="1600" i="1" dirty="0">
+                <a:solidFill>
+                  <a:srgbClr val="555555"/>
                 </a:solidFill>
                 <a:latin typeface="Times New Roman" pitchFamily="34" charset="0"/>
                 <a:ea typeface="Times New Roman" pitchFamily="34" charset="-122"/>
                 <a:cs typeface="Times New Roman" pitchFamily="34" charset="-120"/>
               </a:rPr>
-              <a:t>3. The Geologic Time Scale</a:t>
-            </a:r>
-            <a:endParaRPr lang="en-US" sz="3600" dirty="0"/>
-          </a:p>
-        </p:txBody>
-      </p:sp>
-      <p:sp>
-        <p:nvSpPr>
-          <p:cNvPr id="5" name="Text 2"/>
-          <p:cNvSpPr/>
-          <p:nvPr/>
-        </p:nvSpPr>
-        <p:spPr>
-          <a:xfrm>
-            <a:off x="4069080" y="1737360"/>
-            <a:ext cx="7802575" cy="457200"/>
-          </a:xfrm>
-          <a:prstGeom prst="rect">
-            <a:avLst/>
-          </a:prstGeom>
-          <a:noFill/>
-          <a:ln/>
-        </p:spPr>
-        <p:txBody>
-          <a:bodyPr wrap="square" lIns="0" tIns="0" rIns="0" bIns="0" rtlCol="0" anchor="ctr"/>
-          <a:lstStyle/>
-          <a:p>
-            <a:pPr algn="l" indent="0" marL="0">
-              <a:buNone/>
-            </a:pPr>
-            <a:r>
-              <a:rPr lang="en-US" sz="3200" b="1" dirty="0">
-                <a:solidFill>
-                  <a:srgbClr val="990011"/>
-                </a:solidFill>
-                <a:latin typeface="Times New Roman" pitchFamily="34" charset="0"/>
-                <a:ea typeface="Times New Roman" pitchFamily="34" charset="-122"/>
-                <a:cs typeface="Times New Roman" pitchFamily="34" charset="-120"/>
-              </a:rPr>
-              <a:t>A) The Precambrian and the Palaeozoic</a:t>
-            </a:r>
-            <a:endParaRPr lang="en-US" sz="3200" dirty="0"/>
-          </a:p>
-        </p:txBody>
-      </p:sp>
-      <p:sp>
-        <p:nvSpPr>
-          <p:cNvPr id="6" name="Text 3"/>
-          <p:cNvSpPr/>
-          <p:nvPr/>
-        </p:nvSpPr>
-        <p:spPr>
-          <a:xfrm>
-            <a:off x="4069080" y="2240280"/>
-            <a:ext cx="7802575" cy="4206240"/>
-          </a:xfrm>
-          <a:prstGeom prst="rect">
-            <a:avLst/>
-          </a:prstGeom>
-          <a:noFill/>
-          <a:ln/>
-        </p:spPr>
-        <p:txBody>
-          <a:bodyPr wrap="square" lIns="0" tIns="0" rIns="0" bIns="0" rtlCol="0" anchor="t"/>
-          <a:lstStyle/>
-          <a:p>
-            <a:pPr algn="l" indent="0" marL="0">
-              <a:spcAft>
-                <a:spcPts val="800"/>
-              </a:spcAft>
-              <a:buNone/>
-            </a:pPr>
-            <a:r>
-              <a:rPr lang="en-US" sz="4000" b="1" dirty="0">
-                <a:solidFill>
-                  <a:srgbClr val="111111"/>
-                </a:solidFill>
-                <a:latin typeface="Times New Roman" pitchFamily="34" charset="0"/>
-                <a:ea typeface="Times New Roman" pitchFamily="34" charset="-122"/>
-                <a:cs typeface="Times New Roman" pitchFamily="34" charset="-120"/>
-              </a:rPr>
-              <a:t>Geology of the Precambrian: </a:t>
-            </a:r>
-            <a:pPr algn="l" indent="0" marL="0">
-              <a:spcAft>
-                <a:spcPts val="800"/>
-              </a:spcAft>
-              <a:buNone/>
-            </a:pPr>
-            <a:r>
-              <a:rPr lang="en-US" sz="4000" dirty="0">
-                <a:solidFill>
-                  <a:srgbClr val="111111"/>
-                </a:solidFill>
-                <a:latin typeface="Times New Roman" pitchFamily="34" charset="0"/>
-                <a:ea typeface="Times New Roman" pitchFamily="34" charset="-122"/>
-                <a:cs typeface="Times New Roman" pitchFamily="34" charset="-120"/>
-              </a:rPr>
-              <a:t>The Earth, the first continents, oceans and atmosphere formed; the old rocks of the African Shield, including those of North Cameroon, date from this time.</a:t>
-            </a:r>
-            <a:endParaRPr lang="en-US" sz="4000" dirty="0"/>
+              <a:t>Illustration: stromatolites, the oldest fossils</a:t>
+            </a:r>
+            <a:endParaRPr lang="en-US" sz="1600" dirty="0"/>
           </a:p>
         </p:txBody>
       </p:sp>
@@ -18137,7 +17887,7 @@
         <p:spPr>
           <a:xfrm>
             <a:off x="365760" y="1737360"/>
-            <a:ext cx="5120640" cy="457200"/>
+            <a:ext cx="6035040" cy="457200"/>
           </a:xfrm>
           <a:prstGeom prst="rect">
             <a:avLst/>
@@ -18178,7 +17928,7 @@
         <p:spPr>
           <a:xfrm>
             <a:off x="365760" y="2240280"/>
-            <a:ext cx="4846320" cy="4160520"/>
+            <a:ext cx="6035040" cy="4160520"/>
           </a:xfrm>
           <a:prstGeom prst="rect">
             <a:avLst/>
@@ -18197,7 +17947,7 @@
               <a:buNone/>
             </a:pPr>
             <a:r>
-              <a:rPr lang="en-US" sz="3600" b="1" dirty="0">
+              <a:rPr lang="en-US" sz="3000" b="1" dirty="0">
                 <a:solidFill>
                   <a:srgbClr val="111111"/>
                 </a:solidFill>
@@ -18205,7 +17955,7 @@
                 <a:ea typeface="Times New Roman" pitchFamily="34" charset="-122"/>
                 <a:cs typeface="Times New Roman" pitchFamily="34" charset="-120"/>
               </a:rPr>
-              <a:t>Life in the Precambrian: </a:t>
+              <a:t>Palaeozoic (541 to 252 million years ago): </a:t>
             </a:r>
             <a:pPr algn="l" indent="0" marL="0">
               <a:spcAft>
@@ -18214,7 +17964,7 @@
               <a:buNone/>
             </a:pPr>
             <a:r>
-              <a:rPr lang="en-US" sz="3600" dirty="0">
+              <a:rPr lang="en-US" sz="3000" dirty="0">
                 <a:solidFill>
                   <a:srgbClr val="111111"/>
                 </a:solidFill>
@@ -18222,15 +17972,15 @@
                 <a:ea typeface="Times New Roman" pitchFamily="34" charset="-122"/>
                 <a:cs typeface="Times New Roman" pitchFamily="34" charset="-120"/>
               </a:rPr>
-              <a:t>Simple, single-celled life (bacteria, algae) appeared in the oceans.</a:t>
-            </a:r>
-            <a:endParaRPr lang="en-US" sz="3600" dirty="0"/>
+              <a:t>Its name means ancient life: fish, land plants, insects, amphibians and reptiles appeared, and coal formed from great forests. The continents joined into the supercontinent Pangaea, and a mass extinction ended the era.</a:t>
+            </a:r>
+            <a:endParaRPr lang="en-US" sz="3000" dirty="0"/>
           </a:p>
         </p:txBody>
       </p:sp>
       <p:pic>
         <p:nvPicPr>
-          <p:cNvPr id="6" name="Image 0" descr="/home/claude/f4/img/v2/lsa_stromatolite.jpg">    </p:cNvPr>
+          <p:cNvPr id="6" name="Image 0" descr="/home/claude/f4/img/v2/lsa_trilobite.jpg">    </p:cNvPr>
           <p:cNvPicPr>
             <a:picLocks noChangeAspect="1"/>
           </p:cNvPicPr>
@@ -18244,8 +17994,8 @@
         </p:blipFill>
         <p:spPr>
           <a:xfrm>
-            <a:off x="5349240" y="2071212"/>
-            <a:ext cx="6659575" cy="3693983"/>
+            <a:off x="6537960" y="2400897"/>
+            <a:ext cx="5470855" cy="3034615"/>
           </a:xfrm>
           <a:prstGeom prst="rect">
             <a:avLst/>
@@ -18260,8 +18010,8 @@
         </p:nvSpPr>
         <p:spPr>
           <a:xfrm>
-            <a:off x="5349240" y="6089904"/>
-            <a:ext cx="6659575" cy="347472"/>
+            <a:off x="6537960" y="6089904"/>
+            <a:ext cx="5470855" cy="347472"/>
           </a:xfrm>
           <a:prstGeom prst="rect">
             <a:avLst/>
@@ -18285,7 +18035,7 @@
                 <a:ea typeface="Times New Roman" pitchFamily="34" charset="-122"/>
                 <a:cs typeface="Times New Roman" pitchFamily="34" charset="-120"/>
               </a:rPr>
-              <a:t>Illustration: stromatolites, early life</a:t>
+              <a:t>Illustration: a trilobite fossil</a:t>
             </a:r>
             <a:endParaRPr lang="en-US" sz="1600" dirty="0"/>
           </a:p>
@@ -18453,7 +18203,7 @@
         <p:spPr>
           <a:xfrm>
             <a:off x="365760" y="1737360"/>
-            <a:ext cx="5120640" cy="457200"/>
+            <a:ext cx="6035040" cy="457200"/>
           </a:xfrm>
           <a:prstGeom prst="rect">
             <a:avLst/>
@@ -18479,7 +18229,7 @@
                 <a:ea typeface="Times New Roman" pitchFamily="34" charset="-122"/>
                 <a:cs typeface="Times New Roman" pitchFamily="34" charset="-120"/>
               </a:rPr>
-              <a:t>A) The Precambrian and the Palaeozoic</a:t>
+              <a:t>B) The Mesozoic and the Cenozoic</a:t>
             </a:r>
             <a:endParaRPr lang="en-US" sz="3000" dirty="0"/>
           </a:p>
@@ -18494,7 +18244,7 @@
         <p:spPr>
           <a:xfrm>
             <a:off x="365760" y="2240280"/>
-            <a:ext cx="4846320" cy="4160520"/>
+            <a:ext cx="6035040" cy="4160520"/>
           </a:xfrm>
           <a:prstGeom prst="rect">
             <a:avLst/>
@@ -18513,7 +18263,7 @@
               <a:buNone/>
             </a:pPr>
             <a:r>
-              <a:rPr lang="en-US" sz="3200" b="1" dirty="0">
+              <a:rPr lang="en-US" sz="2600" i="1" dirty="0">
                 <a:solidFill>
                   <a:srgbClr val="111111"/>
                 </a:solidFill>
@@ -18521,8 +18271,11 @@
                 <a:ea typeface="Times New Roman" pitchFamily="34" charset="-122"/>
                 <a:cs typeface="Times New Roman" pitchFamily="34" charset="-120"/>
               </a:rPr>
-              <a:t>Palaeozoic ("ancient life", 541–252 million years ago): </a:t>
-            </a:r>
+              <a:t>The last two eras have the following duration and characteristics:</a:t>
+            </a:r>
+            <a:endParaRPr lang="en-US" sz="2600" dirty="0"/>
+          </a:p>
+          <a:p>
             <a:pPr algn="l" indent="0" marL="0">
               <a:spcAft>
                 <a:spcPts val="800"/>
@@ -18530,7 +18283,7 @@
               <a:buNone/>
             </a:pPr>
             <a:r>
-              <a:rPr lang="en-US" sz="3200" dirty="0">
+              <a:rPr lang="en-US" sz="2600" b="1" dirty="0">
                 <a:solidFill>
                   <a:srgbClr val="111111"/>
                 </a:solidFill>
@@ -18538,15 +18291,32 @@
                 <a:ea typeface="Times New Roman" pitchFamily="34" charset="-122"/>
                 <a:cs typeface="Times New Roman" pitchFamily="34" charset="-120"/>
               </a:rPr>
-              <a:t>The continents joined into Pangaea, fish, land plants, insects and amphibians appeared, and a mass extinction ended the era.</a:t>
-            </a:r>
-            <a:endParaRPr lang="en-US" sz="3200" dirty="0"/>
+              <a:t>Mesozoic (252 to 66 million years ago): </a:t>
+            </a:r>
+            <a:pPr algn="l" indent="0" marL="0">
+              <a:spcAft>
+                <a:spcPts val="800"/>
+              </a:spcAft>
+              <a:buNone/>
+            </a:pPr>
+            <a:r>
+              <a:rPr lang="en-US" sz="2600" dirty="0">
+                <a:solidFill>
+                  <a:srgbClr val="111111"/>
+                </a:solidFill>
+                <a:latin typeface="Times New Roman" pitchFamily="34" charset="0"/>
+                <a:ea typeface="Times New Roman" pitchFamily="34" charset="-122"/>
+                <a:cs typeface="Times New Roman" pitchFamily="34" charset="-120"/>
+              </a:rPr>
+              <a:t>Its name means middle life: dinosaurs dominated the land, and birds, small mammals and flowering plants appeared. Pangaea broke up, the Atlantic Ocean opened, and a mass extinction killed the dinosaurs at its end.</a:t>
+            </a:r>
+            <a:endParaRPr lang="en-US" sz="2600" dirty="0"/>
           </a:p>
         </p:txBody>
       </p:sp>
       <p:pic>
         <p:nvPicPr>
-          <p:cNvPr id="6" name="Image 0" descr="/home/claude/f4/img/v2/lsa_trilobite.jpg">    </p:cNvPr>
+          <p:cNvPr id="6" name="Image 0" descr="/home/claude/f4/img/v2/lsa_dinosaur.jpg">    </p:cNvPr>
           <p:cNvPicPr>
             <a:picLocks noChangeAspect="1"/>
           </p:cNvPicPr>
@@ -18560,8 +18330,8 @@
         </p:blipFill>
         <p:spPr>
           <a:xfrm>
-            <a:off x="5349240" y="2071212"/>
-            <a:ext cx="6659575" cy="3693983"/>
+            <a:off x="6537960" y="2400897"/>
+            <a:ext cx="5470855" cy="3034615"/>
           </a:xfrm>
           <a:prstGeom prst="rect">
             <a:avLst/>
@@ -18576,8 +18346,8 @@
         </p:nvSpPr>
         <p:spPr>
           <a:xfrm>
-            <a:off x="5349240" y="6089904"/>
-            <a:ext cx="6659575" cy="347472"/>
+            <a:off x="6537960" y="6089904"/>
+            <a:ext cx="5470855" cy="347472"/>
           </a:xfrm>
           <a:prstGeom prst="rect">
             <a:avLst/>
@@ -18601,7 +18371,7 @@
                 <a:ea typeface="Times New Roman" pitchFamily="34" charset="-122"/>
                 <a:cs typeface="Times New Roman" pitchFamily="34" charset="-120"/>
               </a:rPr>
-              <a:t>Illustration: a trilobite fossil</a:t>
+              <a:t>Illustration: a dinosaur skeleton</a:t>
             </a:r>
             <a:endParaRPr lang="en-US" sz="1600" dirty="0"/>
           </a:p>
@@ -18719,170 +18489,9 @@
           </a:p>
         </p:txBody>
       </p:sp>
-      <p:sp>
-        <p:nvSpPr>
-          <p:cNvPr id="3" name="Text 1"/>
-          <p:cNvSpPr/>
-          <p:nvPr/>
-        </p:nvSpPr>
-        <p:spPr>
-          <a:xfrm>
-            <a:off x="365760" y="1005840"/>
-            <a:ext cx="11460175" cy="731520"/>
-          </a:xfrm>
-          <a:prstGeom prst="rect">
-            <a:avLst/>
-          </a:prstGeom>
-          <a:noFill/>
-          <a:ln/>
-        </p:spPr>
-        <p:txBody>
-          <a:bodyPr wrap="square" lIns="0" tIns="0" rIns="0" bIns="0" rtlCol="0" anchor="ctr">
-            <a:normAutofit/>
-          </a:bodyPr>
-          <a:lstStyle/>
-          <a:p>
-            <a:pPr algn="ctr" indent="0" marL="0">
-              <a:buNone/>
-            </a:pPr>
-            <a:r>
-              <a:rPr lang="en-US" sz="3600" b="1" dirty="0">
-                <a:solidFill>
-                  <a:srgbClr val="990011"/>
-                </a:solidFill>
-                <a:latin typeface="Times New Roman" pitchFamily="34" charset="0"/>
-                <a:ea typeface="Times New Roman" pitchFamily="34" charset="-122"/>
-                <a:cs typeface="Times New Roman" pitchFamily="34" charset="-120"/>
-              </a:rPr>
-              <a:t>3. The Geologic Time Scale</a:t>
-            </a:r>
-            <a:endParaRPr lang="en-US" sz="3600" dirty="0"/>
-          </a:p>
-        </p:txBody>
-      </p:sp>
-      <p:sp>
-        <p:nvSpPr>
-          <p:cNvPr id="4" name="Text 2"/>
-          <p:cNvSpPr/>
-          <p:nvPr/>
-        </p:nvSpPr>
-        <p:spPr>
-          <a:xfrm>
-            <a:off x="365760" y="1737360"/>
-            <a:ext cx="5120640" cy="457200"/>
-          </a:xfrm>
-          <a:prstGeom prst="rect">
-            <a:avLst/>
-          </a:prstGeom>
-          <a:noFill/>
-          <a:ln/>
-        </p:spPr>
-        <p:txBody>
-          <a:bodyPr wrap="square" lIns="0" tIns="0" rIns="0" bIns="0" rtlCol="0" anchor="ctr">
-            <a:normAutofit/>
-          </a:bodyPr>
-          <a:lstStyle/>
-          <a:p>
-            <a:pPr algn="l" indent="0" marL="0">
-              <a:buNone/>
-            </a:pPr>
-            <a:r>
-              <a:rPr lang="en-US" sz="3000" b="1" dirty="0">
-                <a:solidFill>
-                  <a:srgbClr val="990011"/>
-                </a:solidFill>
-                <a:latin typeface="Times New Roman" pitchFamily="34" charset="0"/>
-                <a:ea typeface="Times New Roman" pitchFamily="34" charset="-122"/>
-                <a:cs typeface="Times New Roman" pitchFamily="34" charset="-120"/>
-              </a:rPr>
-              <a:t>B) The Mesozoic and the Cenozoic</a:t>
-            </a:r>
-            <a:endParaRPr lang="en-US" sz="3000" dirty="0"/>
-          </a:p>
-        </p:txBody>
-      </p:sp>
-      <p:sp>
-        <p:nvSpPr>
-          <p:cNvPr id="5" name="Text 3"/>
-          <p:cNvSpPr/>
-          <p:nvPr/>
-        </p:nvSpPr>
-        <p:spPr>
-          <a:xfrm>
-            <a:off x="365760" y="2240280"/>
-            <a:ext cx="4846320" cy="4160520"/>
-          </a:xfrm>
-          <a:prstGeom prst="rect">
-            <a:avLst/>
-          </a:prstGeom>
-          <a:noFill/>
-          <a:ln/>
-        </p:spPr>
-        <p:txBody>
-          <a:bodyPr wrap="square" lIns="0" tIns="0" rIns="0" bIns="0" rtlCol="0" anchor="t"/>
-          <a:lstStyle/>
-          <a:p>
-            <a:pPr algn="l" indent="0" marL="0">
-              <a:spcAft>
-                <a:spcPts val="800"/>
-              </a:spcAft>
-              <a:buNone/>
-            </a:pPr>
-            <a:r>
-              <a:rPr lang="en-US" sz="3200" i="1" dirty="0">
-                <a:solidFill>
-                  <a:srgbClr val="111111"/>
-                </a:solidFill>
-                <a:latin typeface="Times New Roman" pitchFamily="34" charset="0"/>
-                <a:ea typeface="Times New Roman" pitchFamily="34" charset="-122"/>
-                <a:cs typeface="Times New Roman" pitchFamily="34" charset="-120"/>
-              </a:rPr>
-              <a:t>The last two eras have the following characteristics:</a:t>
-            </a:r>
-            <a:endParaRPr lang="en-US" sz="3200" dirty="0"/>
-          </a:p>
-          <a:p>
-            <a:pPr algn="l" indent="0" marL="0">
-              <a:spcAft>
-                <a:spcPts val="800"/>
-              </a:spcAft>
-              <a:buNone/>
-            </a:pPr>
-            <a:r>
-              <a:rPr lang="en-US" sz="3200" b="1" dirty="0">
-                <a:solidFill>
-                  <a:srgbClr val="111111"/>
-                </a:solidFill>
-                <a:latin typeface="Times New Roman" pitchFamily="34" charset="0"/>
-                <a:ea typeface="Times New Roman" pitchFamily="34" charset="-122"/>
-                <a:cs typeface="Times New Roman" pitchFamily="34" charset="-120"/>
-              </a:rPr>
-              <a:t>Mesozoic ("middle life", 252–66 million years ago): </a:t>
-            </a:r>
-            <a:pPr algn="l" indent="0" marL="0">
-              <a:spcAft>
-                <a:spcPts val="800"/>
-              </a:spcAft>
-              <a:buNone/>
-            </a:pPr>
-            <a:r>
-              <a:rPr lang="en-US" sz="3200" dirty="0">
-                <a:solidFill>
-                  <a:srgbClr val="111111"/>
-                </a:solidFill>
-                <a:latin typeface="Times New Roman" pitchFamily="34" charset="0"/>
-                <a:ea typeface="Times New Roman" pitchFamily="34" charset="-122"/>
-                <a:cs typeface="Times New Roman" pitchFamily="34" charset="-120"/>
-              </a:rPr>
-              <a:t>Pangaea broke up, and dinosaurs dominated the land.</a:t>
-            </a:r>
-            <a:endParaRPr lang="en-US" sz="3200" dirty="0"/>
-          </a:p>
-        </p:txBody>
-      </p:sp>
       <p:pic>
         <p:nvPicPr>
-          <p:cNvPr id="6" name="Image 0" descr="/home/claude/f4/img/v2/lsa_dinosaur.jpg">    </p:cNvPr>
+          <p:cNvPr id="3" name="Image 0" descr="/home/claude/f4/img/minesec_sheet.png">    </p:cNvPr>
           <p:cNvPicPr>
             <a:picLocks noChangeAspect="1"/>
           </p:cNvPicPr>
@@ -18896,8 +18505,8 @@
         </p:blipFill>
         <p:spPr>
           <a:xfrm>
-            <a:off x="5349240" y="2071212"/>
-            <a:ext cx="6659575" cy="3693983"/>
+            <a:off x="0" y="658368"/>
+            <a:ext cx="2468880" cy="5833872"/>
           </a:xfrm>
           <a:prstGeom prst="rect">
             <a:avLst/>
@@ -18906,14 +18515,14 @@
       </p:pic>
       <p:sp>
         <p:nvSpPr>
-          <p:cNvPr id="7" name="Text 4"/>
+          <p:cNvPr id="4" name="Text 1"/>
           <p:cNvSpPr/>
           <p:nvPr/>
         </p:nvSpPr>
         <p:spPr>
           <a:xfrm>
-            <a:off x="5349240" y="6089904"/>
-            <a:ext cx="6659575" cy="347472"/>
+            <a:off x="2697480" y="1005840"/>
+            <a:ext cx="9174175" cy="731520"/>
           </a:xfrm>
           <a:prstGeom prst="rect">
             <a:avLst/>
@@ -18922,24 +18531,124 @@
           <a:ln/>
         </p:spPr>
         <p:txBody>
-          <a:bodyPr wrap="square" lIns="0" tIns="0" rIns="0" bIns="0" rtlCol="0" anchor="ctr"/>
+          <a:bodyPr wrap="square" lIns="0" tIns="0" rIns="0" bIns="0" rtlCol="0" anchor="ctr">
+            <a:normAutofit/>
+          </a:bodyPr>
           <a:lstStyle/>
           <a:p>
             <a:pPr algn="ctr" indent="0" marL="0">
               <a:buNone/>
             </a:pPr>
             <a:r>
-              <a:rPr lang="en-US" sz="1600" i="1" dirty="0">
-                <a:solidFill>
-                  <a:srgbClr val="555555"/>
+              <a:rPr lang="en-US" sz="3600" b="1" dirty="0">
+                <a:solidFill>
+                  <a:srgbClr val="990011"/>
                 </a:solidFill>
                 <a:latin typeface="Times New Roman" pitchFamily="34" charset="0"/>
                 <a:ea typeface="Times New Roman" pitchFamily="34" charset="-122"/>
                 <a:cs typeface="Times New Roman" pitchFamily="34" charset="-120"/>
               </a:rPr>
-              <a:t>Illustration: a dinosaur</a:t>
-            </a:r>
-            <a:endParaRPr lang="en-US" sz="1600" dirty="0"/>
+              <a:t>3. The Geologic Time Scale</a:t>
+            </a:r>
+            <a:endParaRPr lang="en-US" sz="3600" dirty="0"/>
+          </a:p>
+        </p:txBody>
+      </p:sp>
+      <p:sp>
+        <p:nvSpPr>
+          <p:cNvPr id="5" name="Text 2"/>
+          <p:cNvSpPr/>
+          <p:nvPr/>
+        </p:nvSpPr>
+        <p:spPr>
+          <a:xfrm>
+            <a:off x="2697480" y="1737360"/>
+            <a:ext cx="9174175" cy="457200"/>
+          </a:xfrm>
+          <a:prstGeom prst="rect">
+            <a:avLst/>
+          </a:prstGeom>
+          <a:noFill/>
+          <a:ln/>
+        </p:spPr>
+        <p:txBody>
+          <a:bodyPr wrap="square" lIns="0" tIns="0" rIns="0" bIns="0" rtlCol="0" anchor="ctr"/>
+          <a:lstStyle/>
+          <a:p>
+            <a:pPr algn="l" indent="0" marL="0">
+              <a:buNone/>
+            </a:pPr>
+            <a:r>
+              <a:rPr lang="en-US" sz="3200" b="1" dirty="0">
+                <a:solidFill>
+                  <a:srgbClr val="990011"/>
+                </a:solidFill>
+                <a:latin typeface="Times New Roman" pitchFamily="34" charset="0"/>
+                <a:ea typeface="Times New Roman" pitchFamily="34" charset="-122"/>
+                <a:cs typeface="Times New Roman" pitchFamily="34" charset="-120"/>
+              </a:rPr>
+              <a:t>B) The Mesozoic and the Cenozoic</a:t>
+            </a:r>
+            <a:endParaRPr lang="en-US" sz="3200" dirty="0"/>
+          </a:p>
+        </p:txBody>
+      </p:sp>
+      <p:sp>
+        <p:nvSpPr>
+          <p:cNvPr id="6" name="Text 3"/>
+          <p:cNvSpPr/>
+          <p:nvPr/>
+        </p:nvSpPr>
+        <p:spPr>
+          <a:xfrm>
+            <a:off x="2697480" y="2240280"/>
+            <a:ext cx="9174175" cy="4206240"/>
+          </a:xfrm>
+          <a:prstGeom prst="rect">
+            <a:avLst/>
+          </a:prstGeom>
+          <a:noFill/>
+          <a:ln/>
+        </p:spPr>
+        <p:txBody>
+          <a:bodyPr wrap="square" lIns="0" tIns="0" rIns="0" bIns="0" rtlCol="0" anchor="t"/>
+          <a:lstStyle/>
+          <a:p>
+            <a:pPr algn="l" indent="0" marL="0">
+              <a:spcAft>
+                <a:spcPts val="800"/>
+              </a:spcAft>
+              <a:buNone/>
+            </a:pPr>
+            <a:r>
+              <a:rPr lang="en-US" sz="3800" b="1" dirty="0">
+                <a:solidFill>
+                  <a:srgbClr val="111111"/>
+                </a:solidFill>
+                <a:latin typeface="Times New Roman" pitchFamily="34" charset="0"/>
+                <a:ea typeface="Times New Roman" pitchFamily="34" charset="-122"/>
+                <a:cs typeface="Times New Roman" pitchFamily="34" charset="-120"/>
+              </a:rPr>
+              <a:t>Cenozoic (66 million years ago to today): </a:t>
+            </a:r>
+            <a:pPr algn="l" indent="0" marL="0">
+              <a:spcAft>
+                <a:spcPts val="800"/>
+              </a:spcAft>
+              <a:buNone/>
+            </a:pPr>
+            <a:r>
+              <a:rPr lang="en-US" sz="3800" dirty="0">
+                <a:solidFill>
+                  <a:srgbClr val="111111"/>
+                </a:solidFill>
+                <a:latin typeface="Times New Roman" pitchFamily="34" charset="0"/>
+                <a:ea typeface="Times New Roman" pitchFamily="34" charset="-122"/>
+                <a:cs typeface="Times New Roman" pitchFamily="34" charset="-120"/>
+              </a:rPr>
+              <a:t>Its name means recent life: mammals became dominant, and modern humans appeared only about 300,000 years ago. The continents reached their present positions, the Alps and the Himalayas rose, and ice ages occurred.</a:t>
+            </a:r>
+            <a:endParaRPr lang="en-US" sz="3800" dirty="0"/>
           </a:p>
         </p:txBody>
       </p:sp>
@@ -19291,7 +19000,7 @@
         <p:spPr>
           <a:xfrm>
             <a:off x="0" y="658368"/>
-            <a:ext cx="5120640" cy="5833872"/>
+            <a:ext cx="3840480" cy="5833872"/>
           </a:xfrm>
           <a:prstGeom prst="rect">
             <a:avLst/>
@@ -19306,8 +19015,8 @@
         </p:nvSpPr>
         <p:spPr>
           <a:xfrm>
-            <a:off x="5349240" y="1005840"/>
-            <a:ext cx="6522415" cy="731520"/>
+            <a:off x="4069080" y="1005840"/>
+            <a:ext cx="7802575" cy="731520"/>
           </a:xfrm>
           <a:prstGeom prst="rect">
             <a:avLst/>
@@ -19347,8 +19056,8 @@
         </p:nvSpPr>
         <p:spPr>
           <a:xfrm>
-            <a:off x="5349240" y="1737360"/>
-            <a:ext cx="6522415" cy="457200"/>
+            <a:off x="4069080" y="1737360"/>
+            <a:ext cx="7802575" cy="457200"/>
           </a:xfrm>
           <a:prstGeom prst="rect">
             <a:avLst/>
@@ -19386,8 +19095,8 @@
         </p:nvSpPr>
         <p:spPr>
           <a:xfrm>
-            <a:off x="5349240" y="2240280"/>
-            <a:ext cx="6522415" cy="4206240"/>
+            <a:off x="4069080" y="2240280"/>
+            <a:ext cx="7802575" cy="4206240"/>
           </a:xfrm>
           <a:prstGeom prst="rect">
             <a:avLst/>
@@ -19414,7 +19123,7 @@
                 <a:ea typeface="Times New Roman" pitchFamily="34" charset="-122"/>
                 <a:cs typeface="Times New Roman" pitchFamily="34" charset="-120"/>
               </a:rPr>
-              <a:t>Life in the Mesozoic: </a:t>
+              <a:t>The place of man: </a:t>
             </a:r>
             <a:pPr algn="l" indent="0" marL="0">
               <a:spcAft>
@@ -19431,7 +19140,7 @@
                 <a:ea typeface="Times New Roman" pitchFamily="34" charset="-122"/>
                 <a:cs typeface="Times New Roman" pitchFamily="34" charset="-120"/>
               </a:rPr>
-              <a:t>Birds, small mammals and flowering plants appeared; a mass extinction killed the dinosaurs.</a:t>
+              <a:t>If the whole history of the Earth were one day of 24 hours, humans would appear only in the last few seconds. This shows how slowly most landforms have been shaped.</a:t>
             </a:r>
             <a:endParaRPr lang="en-US" sz="4000" dirty="0"/>
           </a:p>
@@ -19543,7 +19252,7 @@
                 <a:ea typeface="Calibri" pitchFamily="34" charset="-122"/>
                 <a:cs typeface="Calibri" pitchFamily="34" charset="-120"/>
               </a:rPr>
-              <a:t>BOARD SUMMARY</a:t>
+              <a:t>FORMATIVE EVALUATION</a:t>
             </a:r>
             <a:endParaRPr lang="en-US" sz="1400" dirty="0"/>
           </a:p>
@@ -19608,7 +19317,7 @@
                 <a:ea typeface="Times New Roman" pitchFamily="34" charset="-122"/>
                 <a:cs typeface="Times New Roman" pitchFamily="34" charset="-120"/>
               </a:rPr>
-              <a:t>3. The Geologic Time Scale</a:t>
+              <a:t>Evaluation 1</a:t>
             </a:r>
             <a:endParaRPr lang="en-US" sz="3600" dirty="0"/>
           </a:p>
@@ -19622,47 +19331,8 @@
         </p:nvSpPr>
         <p:spPr>
           <a:xfrm>
-            <a:off x="5349240" y="1737360"/>
-            <a:ext cx="6522415" cy="457200"/>
-          </a:xfrm>
-          <a:prstGeom prst="rect">
-            <a:avLst/>
-          </a:prstGeom>
-          <a:noFill/>
-          <a:ln/>
-        </p:spPr>
-        <p:txBody>
-          <a:bodyPr wrap="square" lIns="0" tIns="0" rIns="0" bIns="0" rtlCol="0" anchor="ctr"/>
-          <a:lstStyle/>
-          <a:p>
-            <a:pPr algn="l" indent="0" marL="0">
-              <a:buNone/>
-            </a:pPr>
-            <a:r>
-              <a:rPr lang="en-US" sz="2300" b="1" dirty="0">
-                <a:solidFill>
-                  <a:srgbClr val="990011"/>
-                </a:solidFill>
-                <a:latin typeface="Times New Roman" pitchFamily="34" charset="0"/>
-                <a:ea typeface="Times New Roman" pitchFamily="34" charset="-122"/>
-                <a:cs typeface="Times New Roman" pitchFamily="34" charset="-120"/>
-              </a:rPr>
-              <a:t>B) The Mesozoic and the Cenozoic (continued)</a:t>
-            </a:r>
-            <a:endParaRPr lang="en-US" sz="2300" dirty="0"/>
-          </a:p>
-        </p:txBody>
-      </p:sp>
-      <p:sp>
-        <p:nvSpPr>
-          <p:cNvPr id="6" name="Text 3"/>
-          <p:cNvSpPr/>
-          <p:nvPr/>
-        </p:nvSpPr>
-        <p:spPr>
-          <a:xfrm>
-            <a:off x="5349240" y="2240280"/>
-            <a:ext cx="6522415" cy="4206240"/>
+            <a:off x="5349240" y="1783080"/>
+            <a:ext cx="6522415" cy="4663440"/>
           </a:xfrm>
           <a:prstGeom prst="rect">
             <a:avLst/>
@@ -19681,7 +19351,7 @@
               <a:buNone/>
             </a:pPr>
             <a:r>
-              <a:rPr lang="en-US" sz="4000" b="1" dirty="0">
+              <a:rPr lang="en-US" sz="4000" dirty="0">
                 <a:solidFill>
                   <a:srgbClr val="111111"/>
                 </a:solidFill>
@@ -19689,24 +19359,7 @@
                 <a:ea typeface="Times New Roman" pitchFamily="34" charset="-122"/>
                 <a:cs typeface="Times New Roman" pitchFamily="34" charset="-120"/>
               </a:rPr>
-              <a:t>Cenozoic ("recent life", 66 million years ago to today): </a:t>
-            </a:r>
-            <a:pPr algn="l" indent="0" marL="0">
-              <a:spcAft>
-                <a:spcPts val="800"/>
-              </a:spcAft>
-              <a:buNone/>
-            </a:pPr>
-            <a:r>
-              <a:rPr lang="en-US" sz="4000" dirty="0">
-                <a:solidFill>
-                  <a:srgbClr val="111111"/>
-                </a:solidFill>
-                <a:latin typeface="Times New Roman" pitchFamily="34" charset="0"/>
-                <a:ea typeface="Times New Roman" pitchFamily="34" charset="-122"/>
-                <a:cs typeface="Times New Roman" pitchFamily="34" charset="-120"/>
-              </a:rPr>
-              <a:t>The continents reached their present positions, the Alps and Himalayas rose and ice ages occurred.</a:t>
+              <a:t>Distinguish structural geomorphology from dynamic geomorphology.</a:t>
             </a:r>
             <a:endParaRPr lang="en-US" sz="4000" dirty="0"/>
           </a:p>
@@ -19818,7 +19471,7 @@
                 <a:ea typeface="Calibri" pitchFamily="34" charset="-122"/>
                 <a:cs typeface="Calibri" pitchFamily="34" charset="-120"/>
               </a:rPr>
-              <a:t>BOARD SUMMARY</a:t>
+              <a:t>FORMATIVE EVALUATION</a:t>
             </a:r>
             <a:endParaRPr lang="en-US" sz="1400" dirty="0"/>
           </a:p>
@@ -19841,7 +19494,7 @@
         <p:spPr>
           <a:xfrm>
             <a:off x="0" y="658368"/>
-            <a:ext cx="2468880" cy="5833872"/>
+            <a:ext cx="5120640" cy="5833872"/>
           </a:xfrm>
           <a:prstGeom prst="rect">
             <a:avLst/>
@@ -19856,8 +19509,8 @@
         </p:nvSpPr>
         <p:spPr>
           <a:xfrm>
-            <a:off x="2697480" y="1005840"/>
-            <a:ext cx="9174175" cy="731520"/>
+            <a:off x="5349240" y="1005840"/>
+            <a:ext cx="6522415" cy="731520"/>
           </a:xfrm>
           <a:prstGeom prst="rect">
             <a:avLst/>
@@ -19883,7 +19536,7 @@
                 <a:ea typeface="Times New Roman" pitchFamily="34" charset="-122"/>
                 <a:cs typeface="Times New Roman" pitchFamily="34" charset="-120"/>
               </a:rPr>
-              <a:t>3. The Geologic Time Scale</a:t>
+              <a:t>Expected Answer</a:t>
             </a:r>
             <a:endParaRPr lang="en-US" sz="3600" dirty="0"/>
           </a:p>
@@ -19897,47 +19550,8 @@
         </p:nvSpPr>
         <p:spPr>
           <a:xfrm>
-            <a:off x="2697480" y="1737360"/>
-            <a:ext cx="9174175" cy="457200"/>
-          </a:xfrm>
-          <a:prstGeom prst="rect">
-            <a:avLst/>
-          </a:prstGeom>
-          <a:noFill/>
-          <a:ln/>
-        </p:spPr>
-        <p:txBody>
-          <a:bodyPr wrap="square" lIns="0" tIns="0" rIns="0" bIns="0" rtlCol="0" anchor="ctr"/>
-          <a:lstStyle/>
-          <a:p>
-            <a:pPr algn="l" indent="0" marL="0">
-              <a:buNone/>
-            </a:pPr>
-            <a:r>
-              <a:rPr lang="en-US" sz="3200" b="1" dirty="0">
-                <a:solidFill>
-                  <a:srgbClr val="990011"/>
-                </a:solidFill>
-                <a:latin typeface="Times New Roman" pitchFamily="34" charset="0"/>
-                <a:ea typeface="Times New Roman" pitchFamily="34" charset="-122"/>
-                <a:cs typeface="Times New Roman" pitchFamily="34" charset="-120"/>
-              </a:rPr>
-              <a:t>B) The Mesozoic and the Cenozoic (continued)</a:t>
-            </a:r>
-            <a:endParaRPr lang="en-US" sz="3200" dirty="0"/>
-          </a:p>
-        </p:txBody>
-      </p:sp>
-      <p:sp>
-        <p:nvSpPr>
-          <p:cNvPr id="6" name="Text 3"/>
-          <p:cNvSpPr/>
-          <p:nvPr/>
-        </p:nvSpPr>
-        <p:spPr>
-          <a:xfrm>
-            <a:off x="2697480" y="2240280"/>
-            <a:ext cx="9174175" cy="4206240"/>
+            <a:off x="5349240" y="1783080"/>
+            <a:ext cx="6522415" cy="4663440"/>
           </a:xfrm>
           <a:prstGeom prst="rect">
             <a:avLst/>
@@ -19956,7 +19570,7 @@
               <a:buNone/>
             </a:pPr>
             <a:r>
-              <a:rPr lang="en-US" sz="4000" b="1" dirty="0">
+              <a:rPr lang="en-US" sz="4000" dirty="0">
                 <a:solidFill>
                   <a:srgbClr val="111111"/>
                 </a:solidFill>
@@ -19964,61 +19578,7 @@
                 <a:ea typeface="Times New Roman" pitchFamily="34" charset="-122"/>
                 <a:cs typeface="Times New Roman" pitchFamily="34" charset="-120"/>
               </a:rPr>
-              <a:t>Life in the Cenozoic: </a:t>
-            </a:r>
-            <a:pPr algn="l" indent="0" marL="0">
-              <a:spcAft>
-                <a:spcPts val="800"/>
-              </a:spcAft>
-              <a:buNone/>
-            </a:pPr>
-            <a:r>
-              <a:rPr lang="en-US" sz="4000" dirty="0">
-                <a:solidFill>
-                  <a:srgbClr val="111111"/>
-                </a:solidFill>
-                <a:latin typeface="Times New Roman" pitchFamily="34" charset="0"/>
-                <a:ea typeface="Times New Roman" pitchFamily="34" charset="-122"/>
-                <a:cs typeface="Times New Roman" pitchFamily="34" charset="-120"/>
-              </a:rPr>
-              <a:t>Mammals became dominant, and modern humans appeared only about 300,000 years ago.</a:t>
-            </a:r>
-            <a:endParaRPr lang="en-US" sz="4000" dirty="0"/>
-          </a:p>
-          <a:p>
-            <a:pPr algn="l" indent="0" marL="0">
-              <a:spcAft>
-                <a:spcPts val="800"/>
-              </a:spcAft>
-              <a:buNone/>
-            </a:pPr>
-            <a:r>
-              <a:rPr lang="en-US" sz="4000" b="1" dirty="0">
-                <a:solidFill>
-                  <a:srgbClr val="111111"/>
-                </a:solidFill>
-                <a:latin typeface="Times New Roman" pitchFamily="34" charset="0"/>
-                <a:ea typeface="Times New Roman" pitchFamily="34" charset="-122"/>
-                <a:cs typeface="Times New Roman" pitchFamily="34" charset="-120"/>
-              </a:rPr>
-              <a:t>Human history: </a:t>
-            </a:r>
-            <a:pPr algn="l" indent="0" marL="0">
-              <a:spcAft>
-                <a:spcPts val="800"/>
-              </a:spcAft>
-              <a:buNone/>
-            </a:pPr>
-            <a:r>
-              <a:rPr lang="en-US" sz="4000" dirty="0">
-                <a:solidFill>
-                  <a:srgbClr val="111111"/>
-                </a:solidFill>
-                <a:latin typeface="Times New Roman" pitchFamily="34" charset="0"/>
-                <a:ea typeface="Times New Roman" pitchFamily="34" charset="-122"/>
-                <a:cs typeface="Times New Roman" pitchFamily="34" charset="-120"/>
-              </a:rPr>
-              <a:t>If the history of the Earth were one day, humans would appear only in the last few seconds.</a:t>
+              <a:t>Structural geomorphology studies landforms made by internal structure and forces; dynamic geomorphology studies landforms made by external agents.</a:t>
             </a:r>
             <a:endParaRPr lang="en-US" sz="4000" dirty="0"/>
           </a:p>
@@ -20195,7 +19755,7 @@
                 <a:ea typeface="Times New Roman" pitchFamily="34" charset="-122"/>
                 <a:cs typeface="Times New Roman" pitchFamily="34" charset="-120"/>
               </a:rPr>
-              <a:t>Evaluation 1</a:t>
+              <a:t>Evaluation 2</a:t>
             </a:r>
             <a:endParaRPr lang="en-US" sz="3600" dirty="0"/>
           </a:p>
@@ -20237,7 +19797,7 @@
                 <a:ea typeface="Times New Roman" pitchFamily="34" charset="-122"/>
                 <a:cs typeface="Times New Roman" pitchFamily="34" charset="-120"/>
               </a:rPr>
-              <a:t>Distinguish structural geomorphology from dynamic geomorphology.</a:t>
+              <a:t>Give one geological and one biological event of the Mesozoic.</a:t>
             </a:r>
             <a:endParaRPr lang="en-US" sz="4000" dirty="0"/>
           </a:p>
@@ -20456,7 +20016,7 @@
                 <a:ea typeface="Times New Roman" pitchFamily="34" charset="-122"/>
                 <a:cs typeface="Times New Roman" pitchFamily="34" charset="-120"/>
               </a:rPr>
-              <a:t>Structural geomorphology studies landforms made by internal structure and forces; dynamic geomorphology studies landforms made by external agents.</a:t>
+              <a:t>Pangaea broke up; dinosaurs dominated the land.</a:t>
             </a:r>
             <a:endParaRPr lang="en-US" sz="4000" dirty="0"/>
           </a:p>
@@ -20568,7 +20128,7 @@
                 <a:ea typeface="Calibri" pitchFamily="34" charset="-122"/>
                 <a:cs typeface="Calibri" pitchFamily="34" charset="-120"/>
               </a:rPr>
-              <a:t>FORMATIVE EVALUATION</a:t>
+              <a:t>REMEDIATION</a:t>
             </a:r>
             <a:endParaRPr lang="en-US" sz="1400" dirty="0"/>
           </a:p>
@@ -20591,7 +20151,7 @@
         <p:spPr>
           <a:xfrm>
             <a:off x="0" y="658368"/>
-            <a:ext cx="5120640" cy="5833872"/>
+            <a:ext cx="3840480" cy="5833872"/>
           </a:xfrm>
           <a:prstGeom prst="rect">
             <a:avLst/>
@@ -20606,8 +20166,8 @@
         </p:nvSpPr>
         <p:spPr>
           <a:xfrm>
-            <a:off x="5349240" y="1005840"/>
-            <a:ext cx="6522415" cy="731520"/>
+            <a:off x="4069080" y="1005840"/>
+            <a:ext cx="7802575" cy="731520"/>
           </a:xfrm>
           <a:prstGeom prst="rect">
             <a:avLst/>
@@ -20633,7 +20193,7 @@
                 <a:ea typeface="Times New Roman" pitchFamily="34" charset="-122"/>
                 <a:cs typeface="Times New Roman" pitchFamily="34" charset="-120"/>
               </a:rPr>
-              <a:t>Evaluation 2</a:t>
+              <a:t>Remediation</a:t>
             </a:r>
             <a:endParaRPr lang="en-US" sz="3600" dirty="0"/>
           </a:p>
@@ -20647,8 +20207,8 @@
         </p:nvSpPr>
         <p:spPr>
           <a:xfrm>
-            <a:off x="5349240" y="1783080"/>
-            <a:ext cx="6522415" cy="4663440"/>
+            <a:off x="4069080" y="1783080"/>
+            <a:ext cx="7802575" cy="4663440"/>
           </a:xfrm>
           <a:prstGeom prst="rect">
             <a:avLst/>
@@ -20667,7 +20227,7 @@
               <a:buNone/>
             </a:pPr>
             <a:r>
-              <a:rPr lang="en-US" sz="4000" dirty="0">
+              <a:rPr lang="en-US" sz="4000" b="1" dirty="0">
                 <a:solidFill>
                   <a:srgbClr val="111111"/>
                 </a:solidFill>
@@ -20675,7 +20235,73 @@
                 <a:ea typeface="Times New Roman" pitchFamily="34" charset="-122"/>
                 <a:cs typeface="Times New Roman" pitchFamily="34" charset="-120"/>
               </a:rPr>
-              <a:t>Give one geological and one biological event of the Mesozoic.</a:t>
+              <a:t>Fill in the blanks:</a:t>
+            </a:r>
+            <a:endParaRPr lang="en-US" sz="4000" dirty="0"/>
+          </a:p>
+          <a:p>
+            <a:pPr algn="l" marL="342900" indent="-342900">
+              <a:spcAft>
+                <a:spcPts val="800"/>
+              </a:spcAft>
+              <a:buSzPct val="100000"/>
+              <a:buFont typeface="+mj-lt"/>
+              <a:buAutoNum type="arabicPeriod" startAt="1"/>
+            </a:pPr>
+            <a:r>
+              <a:rPr lang="en-US" sz="4000" dirty="0">
+                <a:solidFill>
+                  <a:srgbClr val="111111"/>
+                </a:solidFill>
+                <a:latin typeface="Times New Roman" pitchFamily="34" charset="0"/>
+                <a:ea typeface="Times New Roman" pitchFamily="34" charset="-122"/>
+                <a:cs typeface="Times New Roman" pitchFamily="34" charset="-120"/>
+              </a:rPr>
+              <a:t>The Earth formed about ______ billion years ago.</a:t>
+            </a:r>
+            <a:endParaRPr lang="en-US" sz="4000" dirty="0"/>
+          </a:p>
+          <a:p>
+            <a:pPr algn="l" marL="342900" indent="-342900">
+              <a:spcAft>
+                <a:spcPts val="800"/>
+              </a:spcAft>
+              <a:buSzPct val="100000"/>
+              <a:buFont typeface="+mj-lt"/>
+              <a:buAutoNum type="arabicPeriod" startAt="1"/>
+            </a:pPr>
+            <a:r>
+              <a:rPr lang="en-US" sz="4000" dirty="0">
+                <a:solidFill>
+                  <a:srgbClr val="111111"/>
+                </a:solidFill>
+                <a:latin typeface="Times New Roman" pitchFamily="34" charset="0"/>
+                <a:ea typeface="Times New Roman" pitchFamily="34" charset="-122"/>
+                <a:cs typeface="Times New Roman" pitchFamily="34" charset="-120"/>
+              </a:rPr>
+              <a:t>The longest era is the ______.</a:t>
+            </a:r>
+            <a:endParaRPr lang="en-US" sz="4000" dirty="0"/>
+          </a:p>
+          <a:p>
+            <a:pPr algn="l" marL="342900" indent="-342900">
+              <a:spcAft>
+                <a:spcPts val="800"/>
+              </a:spcAft>
+              <a:buSzPct val="100000"/>
+              <a:buFont typeface="+mj-lt"/>
+              <a:buAutoNum type="arabicPeriod" startAt="1"/>
+            </a:pPr>
+            <a:r>
+              <a:rPr lang="en-US" sz="4000" dirty="0">
+                <a:solidFill>
+                  <a:srgbClr val="111111"/>
+                </a:solidFill>
+                <a:latin typeface="Times New Roman" pitchFamily="34" charset="0"/>
+                <a:ea typeface="Times New Roman" pitchFamily="34" charset="-122"/>
+                <a:cs typeface="Times New Roman" pitchFamily="34" charset="-120"/>
+              </a:rPr>
+              <a:t>The Cenozoic is the age of ______.</a:t>
             </a:r>
             <a:endParaRPr lang="en-US" sz="4000" dirty="0"/>
           </a:p>
@@ -20787,7 +20413,7 @@
                 <a:ea typeface="Calibri" pitchFamily="34" charset="-122"/>
                 <a:cs typeface="Calibri" pitchFamily="34" charset="-120"/>
               </a:rPr>
-              <a:t>FORMATIVE EVALUATION</a:t>
+              <a:t>HOMEWORK</a:t>
             </a:r>
             <a:endParaRPr lang="en-US" sz="1400" dirty="0"/>
           </a:p>
@@ -20852,7 +20478,7 @@
                 <a:ea typeface="Times New Roman" pitchFamily="34" charset="-122"/>
                 <a:cs typeface="Times New Roman" pitchFamily="34" charset="-120"/>
               </a:rPr>
-              <a:t>Expected Answer</a:t>
+              <a:t>Homework</a:t>
             </a:r>
             <a:endParaRPr lang="en-US" sz="3600" dirty="0"/>
           </a:p>
@@ -20894,7 +20520,7 @@
                 <a:ea typeface="Times New Roman" pitchFamily="34" charset="-122"/>
                 <a:cs typeface="Times New Roman" pitchFamily="34" charset="-120"/>
               </a:rPr>
-              <a:t>Pangaea broke up; dinosaurs dominated the land.</a:t>
+              <a:t>Name the three main layers of the Earth.</a:t>
             </a:r>
             <a:endParaRPr lang="en-US" sz="4000" dirty="0"/>
           </a:p>
@@ -21006,7 +20632,7 @@
                 <a:ea typeface="Calibri" pitchFamily="34" charset="-122"/>
                 <a:cs typeface="Calibri" pitchFamily="34" charset="-120"/>
               </a:rPr>
-              <a:t>REMEDIATION</a:t>
+              <a:t>NEXT LESSON</a:t>
             </a:r>
             <a:endParaRPr lang="en-US" sz="1400" dirty="0"/>
           </a:p>
@@ -21029,7 +20655,7 @@
         <p:spPr>
           <a:xfrm>
             <a:off x="0" y="658368"/>
-            <a:ext cx="3840480" cy="5833872"/>
+            <a:ext cx="5120640" cy="5833872"/>
           </a:xfrm>
           <a:prstGeom prst="rect">
             <a:avLst/>
@@ -21044,8 +20670,8 @@
         </p:nvSpPr>
         <p:spPr>
           <a:xfrm>
-            <a:off x="4069080" y="1005840"/>
-            <a:ext cx="7802575" cy="731520"/>
+            <a:off x="5349240" y="1005840"/>
+            <a:ext cx="6522415" cy="731520"/>
           </a:xfrm>
           <a:prstGeom prst="rect">
             <a:avLst/>
@@ -21071,7 +20697,7 @@
                 <a:ea typeface="Times New Roman" pitchFamily="34" charset="-122"/>
                 <a:cs typeface="Times New Roman" pitchFamily="34" charset="-120"/>
               </a:rPr>
-              <a:t>Remediation</a:t>
+              <a:t>Next Lesson</a:t>
             </a:r>
             <a:endParaRPr lang="en-US" sz="3600" dirty="0"/>
           </a:p>
@@ -21085,8 +20711,8 @@
         </p:nvSpPr>
         <p:spPr>
           <a:xfrm>
-            <a:off x="4069080" y="1783080"/>
-            <a:ext cx="7802575" cy="4663440"/>
+            <a:off x="5349240" y="1783080"/>
+            <a:ext cx="6522415" cy="4663440"/>
           </a:xfrm>
           <a:prstGeom prst="rect">
             <a:avLst/>
@@ -21095,10 +20721,10 @@
           <a:ln/>
         </p:spPr>
         <p:txBody>
-          <a:bodyPr wrap="square" lIns="0" tIns="0" rIns="0" bIns="0" rtlCol="0" anchor="t"/>
-          <a:lstStyle/>
-          <a:p>
-            <a:pPr algn="l" indent="0" marL="0">
+          <a:bodyPr wrap="square" lIns="0" tIns="0" rIns="0" bIns="0" rtlCol="0" anchor="ctr"/>
+          <a:lstStyle/>
+          <a:p>
+            <a:pPr algn="ctr" indent="0" marL="0">
               <a:spcAft>
                 <a:spcPts val="800"/>
               </a:spcAft>
@@ -21113,73 +20739,27 @@
                 <a:ea typeface="Times New Roman" pitchFamily="34" charset="-122"/>
                 <a:cs typeface="Times New Roman" pitchFamily="34" charset="-120"/>
               </a:rPr>
-              <a:t>Fill in the blanks:</a:t>
+              <a:t>Our next lesson will be on:</a:t>
             </a:r>
             <a:endParaRPr lang="en-US" sz="4000" dirty="0"/>
           </a:p>
           <a:p>
-            <a:pPr algn="l" marL="342900" indent="-342900">
+            <a:pPr algn="ctr" indent="0" marL="0">
               <a:spcAft>
                 <a:spcPts val="800"/>
               </a:spcAft>
-              <a:buSzPct val="100000"/>
-              <a:buFont typeface="+mj-lt"/>
-              <a:buAutoNum type="arabicPeriod" startAt="1"/>
-            </a:pPr>
-            <a:r>
-              <a:rPr lang="en-US" sz="4000" dirty="0">
-                <a:solidFill>
-                  <a:srgbClr val="111111"/>
+              <a:buNone/>
+            </a:pPr>
+            <a:r>
+              <a:rPr lang="en-US" sz="4000" b="1" dirty="0">
+                <a:solidFill>
+                  <a:srgbClr val="990011"/>
                 </a:solidFill>
                 <a:latin typeface="Times New Roman" pitchFamily="34" charset="0"/>
                 <a:ea typeface="Times New Roman" pitchFamily="34" charset="-122"/>
                 <a:cs typeface="Times New Roman" pitchFamily="34" charset="-120"/>
               </a:rPr>
-              <a:t>The Earth formed about ______ billion years ago.</a:t>
-            </a:r>
-            <a:endParaRPr lang="en-US" sz="4000" dirty="0"/>
-          </a:p>
-          <a:p>
-            <a:pPr algn="l" marL="342900" indent="-342900">
-              <a:spcAft>
-                <a:spcPts val="800"/>
-              </a:spcAft>
-              <a:buSzPct val="100000"/>
-              <a:buFont typeface="+mj-lt"/>
-              <a:buAutoNum type="arabicPeriod" startAt="1"/>
-            </a:pPr>
-            <a:r>
-              <a:rPr lang="en-US" sz="4000" dirty="0">
-                <a:solidFill>
-                  <a:srgbClr val="111111"/>
-                </a:solidFill>
-                <a:latin typeface="Times New Roman" pitchFamily="34" charset="0"/>
-                <a:ea typeface="Times New Roman" pitchFamily="34" charset="-122"/>
-                <a:cs typeface="Times New Roman" pitchFamily="34" charset="-120"/>
-              </a:rPr>
-              <a:t>The longest era is the ______.</a:t>
-            </a:r>
-            <a:endParaRPr lang="en-US" sz="4000" dirty="0"/>
-          </a:p>
-          <a:p>
-            <a:pPr algn="l" marL="342900" indent="-342900">
-              <a:spcAft>
-                <a:spcPts val="800"/>
-              </a:spcAft>
-              <a:buSzPct val="100000"/>
-              <a:buFont typeface="+mj-lt"/>
-              <a:buAutoNum type="arabicPeriod" startAt="1"/>
-            </a:pPr>
-            <a:r>
-              <a:rPr lang="en-US" sz="4000" dirty="0">
-                <a:solidFill>
-                  <a:srgbClr val="111111"/>
-                </a:solidFill>
-                <a:latin typeface="Times New Roman" pitchFamily="34" charset="0"/>
-                <a:ea typeface="Times New Roman" pitchFamily="34" charset="-122"/>
-                <a:cs typeface="Times New Roman" pitchFamily="34" charset="-120"/>
-              </a:rPr>
-              <a:t>The Cenozoic is the age of ______.</a:t>
+              <a:t>Lesson 2: Internal Structure of the Earth</a:t>
             </a:r>
             <a:endParaRPr lang="en-US" sz="4000" dirty="0"/>
           </a:p>
@@ -21291,46 +20871,22 @@
                 <a:ea typeface="Calibri" pitchFamily="34" charset="-122"/>
                 <a:cs typeface="Calibri" pitchFamily="34" charset="-120"/>
               </a:rPr>
-              <a:t>HOMEWORK</a:t>
+              <a:t>BILINGUAL GAME</a:t>
             </a:r>
             <a:endParaRPr lang="en-US" sz="1400" dirty="0"/>
           </a:p>
         </p:txBody>
       </p:sp>
-      <p:pic>
-        <p:nvPicPr>
-          <p:cNvPr id="3" name="Image 0" descr="/home/claude/f4/img/minesec_sheet.png">    </p:cNvPr>
-          <p:cNvPicPr>
-            <a:picLocks noChangeAspect="1"/>
-          </p:cNvPicPr>
-          <p:nvPr/>
-        </p:nvPicPr>
-        <p:blipFill>
-          <a:blip r:embed="rId1"/>
-          <a:stretch>
-            <a:fillRect/>
-          </a:stretch>
-        </p:blipFill>
-        <p:spPr>
-          <a:xfrm>
-            <a:off x="0" y="658368"/>
-            <a:ext cx="5120640" cy="5833872"/>
-          </a:xfrm>
-          <a:prstGeom prst="rect">
-            <a:avLst/>
-          </a:prstGeom>
-        </p:spPr>
-      </p:pic>
-      <p:sp>
-        <p:nvSpPr>
-          <p:cNvPr id="4" name="Text 1"/>
+      <p:sp>
+        <p:nvSpPr>
+          <p:cNvPr id="3" name="Text 1"/>
           <p:cNvSpPr/>
           <p:nvPr/>
         </p:nvSpPr>
         <p:spPr>
           <a:xfrm>
-            <a:off x="5349240" y="1005840"/>
-            <a:ext cx="6522415" cy="731520"/>
+            <a:off x="457200" y="1005840"/>
+            <a:ext cx="11277295" cy="731520"/>
           </a:xfrm>
           <a:prstGeom prst="rect">
             <a:avLst/>
@@ -21339,9 +20895,7 @@
           <a:ln/>
         </p:spPr>
         <p:txBody>
-          <a:bodyPr wrap="square" lIns="0" tIns="0" rIns="0" bIns="0" rtlCol="0" anchor="ctr">
-            <a:normAutofit/>
-          </a:bodyPr>
+          <a:bodyPr wrap="square" lIns="0" tIns="0" rIns="0" bIns="0" rtlCol="0" anchor="ctr"/>
           <a:lstStyle/>
           <a:p>
             <a:pPr algn="ctr" indent="0" marL="0">
@@ -21356,769 +20910,6 @@
                 <a:ea typeface="Times New Roman" pitchFamily="34" charset="-122"/>
                 <a:cs typeface="Times New Roman" pitchFamily="34" charset="-120"/>
               </a:rPr>
-              <a:t>Homework</a:t>
-            </a:r>
-            <a:endParaRPr lang="en-US" sz="3600" dirty="0"/>
-          </a:p>
-        </p:txBody>
-      </p:sp>
-      <p:sp>
-        <p:nvSpPr>
-          <p:cNvPr id="5" name="Text 2"/>
-          <p:cNvSpPr/>
-          <p:nvPr/>
-        </p:nvSpPr>
-        <p:spPr>
-          <a:xfrm>
-            <a:off x="5349240" y="1783080"/>
-            <a:ext cx="6522415" cy="4663440"/>
-          </a:xfrm>
-          <a:prstGeom prst="rect">
-            <a:avLst/>
-          </a:prstGeom>
-          <a:noFill/>
-          <a:ln/>
-        </p:spPr>
-        <p:txBody>
-          <a:bodyPr wrap="square" lIns="0" tIns="0" rIns="0" bIns="0" rtlCol="0" anchor="t"/>
-          <a:lstStyle/>
-          <a:p>
-            <a:pPr algn="l" indent="0" marL="0">
-              <a:spcAft>
-                <a:spcPts val="800"/>
-              </a:spcAft>
-              <a:buNone/>
-            </a:pPr>
-            <a:r>
-              <a:rPr lang="en-US" sz="4000" dirty="0">
-                <a:solidFill>
-                  <a:srgbClr val="111111"/>
-                </a:solidFill>
-                <a:latin typeface="Times New Roman" pitchFamily="34" charset="0"/>
-                <a:ea typeface="Times New Roman" pitchFamily="34" charset="-122"/>
-                <a:cs typeface="Times New Roman" pitchFamily="34" charset="-120"/>
-              </a:rPr>
-              <a:t>Name the three main layers of the Earth.</a:t>
-            </a:r>
-            <a:endParaRPr lang="en-US" sz="4000" dirty="0"/>
-          </a:p>
-        </p:txBody>
-      </p:sp>
-      <p:sp>
-        <p:nvSpPr>
-          <p:cNvPr id="25" name="Slide Number Placeholder 0"/>
-          <p:cNvSpPr>
-            <a:spLocks noGrp="1"/>
-          </p:cNvSpPr>
-          <p:nvPr>
-            <p:ph type="sldNum" sz="quarter" idx="4294967295"/>
-          </p:nvPr>
-        </p:nvSpPr>
-        <p:spPr>
-          <a:xfrm>
-            <a:off x="27432" y="91440"/>
-            <a:ext cx="585216" cy="475488"/>
-          </a:xfrm>
-          <a:prstGeom prst="rect">
-            <a:avLst/>
-          </a:prstGeom>
-          <a:extLst>
-            <a:ext uri="{C572A759-6A51-4108-AA02-DFA0A04FC94B}">
-              <ma14:wrappingTextBoxFlag xmlns:ma14="http://schemas.microsoft.com/office/mac/drawingml/2011/main" val="0"/>
-            </a:ext>
-          </a:extLst>
-        </p:spPr>
-        <p:txBody>
-          <a:bodyPr/>
-          <a:lstStyle>
-            <a:lvl1pPr>
-              <a:defRPr sz="2000">
-                <a:solidFill>
-                  <a:srgbClr val="FFFFFF"/>
-                </a:solidFill>
-                <a:latin typeface="Calibri"/>
-                <a:ea typeface="Calibri"/>
-                <a:cs typeface="Calibri"/>
-              </a:defRPr>
-            </a:lvl1pPr>
-          </a:lstStyle>
-          <a:p>
-            <a:pPr algn="ctr"/>
-            <a:fld id="{F7021451-1387-4CA6-816F-3879F97B5CBC}" type="slidenum">
-              <a:rPr b="1" lang="en-US"/>
-              <a:t>58</a:t>
-            </a:fld>
-            <a:endParaRPr lang="en-US"/>
-          </a:p>
-        </p:txBody>
-      </p:sp>
-    </p:spTree>
-  </p:cSld>
-  <p:clrMapOvr>
-    <a:masterClrMapping/>
-  </p:clrMapOvr>
-</p:sld>
-</file>
-
-<file path=ppt/slides/slide59.xml><?xml version="1.0" encoding="utf-8"?>
-<p:sld xmlns:a="http://schemas.openxmlformats.org/drawingml/2006/main" xmlns:r="http://schemas.openxmlformats.org/officeDocument/2006/relationships" xmlns:p="http://schemas.openxmlformats.org/presentationml/2006/main">
-  <p:cSld name="Slide 59">
-    <p:spTree>
-      <p:nvGrpSpPr>
-        <p:cNvPr id="1" name=""/>
-        <p:cNvGrpSpPr/>
-        <p:nvPr/>
-      </p:nvGrpSpPr>
-      <p:grpSpPr>
-        <a:xfrm>
-          <a:off x="0" y="0"/>
-          <a:ext cx="0" cy="0"/>
-          <a:chOff x="0" y="0"/>
-          <a:chExt cx="0" cy="0"/>
-        </a:xfrm>
-      </p:grpSpPr>
-      <p:sp>
-        <p:nvSpPr>
-          <p:cNvPr id="2" name="Text 0"/>
-          <p:cNvSpPr/>
-          <p:nvPr/>
-        </p:nvSpPr>
-        <p:spPr>
-          <a:xfrm>
-            <a:off x="457200" y="713232"/>
-            <a:ext cx="11368735" cy="274320"/>
-          </a:xfrm>
-          <a:prstGeom prst="rect">
-            <a:avLst/>
-          </a:prstGeom>
-          <a:noFill/>
-          <a:ln/>
-        </p:spPr>
-        <p:txBody>
-          <a:bodyPr wrap="square" lIns="0" tIns="0" rIns="0" bIns="0" rtlCol="0" anchor="ctr"/>
-          <a:lstStyle/>
-          <a:p>
-            <a:pPr algn="r" indent="0" marL="0">
-              <a:buNone/>
-            </a:pPr>
-            <a:r>
-              <a:rPr lang="en-US" sz="1400" b="1" dirty="0">
-                <a:solidFill>
-                  <a:srgbClr val="1C3F6E"/>
-                </a:solidFill>
-                <a:latin typeface="Calibri" pitchFamily="34" charset="0"/>
-                <a:ea typeface="Calibri" pitchFamily="34" charset="-122"/>
-                <a:cs typeface="Calibri" pitchFamily="34" charset="-120"/>
-              </a:rPr>
-              <a:t>NEXT LESSON</a:t>
-            </a:r>
-            <a:endParaRPr lang="en-US" sz="1400" dirty="0"/>
-          </a:p>
-        </p:txBody>
-      </p:sp>
-      <p:pic>
-        <p:nvPicPr>
-          <p:cNvPr id="3" name="Image 0" descr="/home/claude/f4/img/minesec_sheet.png">    </p:cNvPr>
-          <p:cNvPicPr>
-            <a:picLocks noChangeAspect="1"/>
-          </p:cNvPicPr>
-          <p:nvPr/>
-        </p:nvPicPr>
-        <p:blipFill>
-          <a:blip r:embed="rId1"/>
-          <a:stretch>
-            <a:fillRect/>
-          </a:stretch>
-        </p:blipFill>
-        <p:spPr>
-          <a:xfrm>
-            <a:off x="0" y="658368"/>
-            <a:ext cx="5120640" cy="5833872"/>
-          </a:xfrm>
-          <a:prstGeom prst="rect">
-            <a:avLst/>
-          </a:prstGeom>
-        </p:spPr>
-      </p:pic>
-      <p:sp>
-        <p:nvSpPr>
-          <p:cNvPr id="4" name="Text 1"/>
-          <p:cNvSpPr/>
-          <p:nvPr/>
-        </p:nvSpPr>
-        <p:spPr>
-          <a:xfrm>
-            <a:off x="5349240" y="1005840"/>
-            <a:ext cx="6522415" cy="731520"/>
-          </a:xfrm>
-          <a:prstGeom prst="rect">
-            <a:avLst/>
-          </a:prstGeom>
-          <a:noFill/>
-          <a:ln/>
-        </p:spPr>
-        <p:txBody>
-          <a:bodyPr wrap="square" lIns="0" tIns="0" rIns="0" bIns="0" rtlCol="0" anchor="ctr">
-            <a:normAutofit/>
-          </a:bodyPr>
-          <a:lstStyle/>
-          <a:p>
-            <a:pPr algn="ctr" indent="0" marL="0">
-              <a:buNone/>
-            </a:pPr>
-            <a:r>
-              <a:rPr lang="en-US" sz="3600" b="1" dirty="0">
-                <a:solidFill>
-                  <a:srgbClr val="990011"/>
-                </a:solidFill>
-                <a:latin typeface="Times New Roman" pitchFamily="34" charset="0"/>
-                <a:ea typeface="Times New Roman" pitchFamily="34" charset="-122"/>
-                <a:cs typeface="Times New Roman" pitchFamily="34" charset="-120"/>
-              </a:rPr>
-              <a:t>Next Lesson</a:t>
-            </a:r>
-            <a:endParaRPr lang="en-US" sz="3600" dirty="0"/>
-          </a:p>
-        </p:txBody>
-      </p:sp>
-      <p:sp>
-        <p:nvSpPr>
-          <p:cNvPr id="5" name="Text 2"/>
-          <p:cNvSpPr/>
-          <p:nvPr/>
-        </p:nvSpPr>
-        <p:spPr>
-          <a:xfrm>
-            <a:off x="5349240" y="1783080"/>
-            <a:ext cx="6522415" cy="4663440"/>
-          </a:xfrm>
-          <a:prstGeom prst="rect">
-            <a:avLst/>
-          </a:prstGeom>
-          <a:noFill/>
-          <a:ln/>
-        </p:spPr>
-        <p:txBody>
-          <a:bodyPr wrap="square" lIns="0" tIns="0" rIns="0" bIns="0" rtlCol="0" anchor="ctr"/>
-          <a:lstStyle/>
-          <a:p>
-            <a:pPr algn="ctr" indent="0" marL="0">
-              <a:spcAft>
-                <a:spcPts val="800"/>
-              </a:spcAft>
-              <a:buNone/>
-            </a:pPr>
-            <a:r>
-              <a:rPr lang="en-US" sz="4000" b="1" dirty="0">
-                <a:solidFill>
-                  <a:srgbClr val="111111"/>
-                </a:solidFill>
-                <a:latin typeface="Times New Roman" pitchFamily="34" charset="0"/>
-                <a:ea typeface="Times New Roman" pitchFamily="34" charset="-122"/>
-                <a:cs typeface="Times New Roman" pitchFamily="34" charset="-120"/>
-              </a:rPr>
-              <a:t>Our next lesson will be on:</a:t>
-            </a:r>
-            <a:endParaRPr lang="en-US" sz="4000" dirty="0"/>
-          </a:p>
-          <a:p>
-            <a:pPr algn="ctr" indent="0" marL="0">
-              <a:spcAft>
-                <a:spcPts val="800"/>
-              </a:spcAft>
-              <a:buNone/>
-            </a:pPr>
-            <a:r>
-              <a:rPr lang="en-US" sz="4000" b="1" dirty="0">
-                <a:solidFill>
-                  <a:srgbClr val="990011"/>
-                </a:solidFill>
-                <a:latin typeface="Times New Roman" pitchFamily="34" charset="0"/>
-                <a:ea typeface="Times New Roman" pitchFamily="34" charset="-122"/>
-                <a:cs typeface="Times New Roman" pitchFamily="34" charset="-120"/>
-              </a:rPr>
-              <a:t>Lesson 2: Internal Structure of the Earth</a:t>
-            </a:r>
-            <a:endParaRPr lang="en-US" sz="4000" dirty="0"/>
-          </a:p>
-        </p:txBody>
-      </p:sp>
-      <p:sp>
-        <p:nvSpPr>
-          <p:cNvPr id="25" name="Slide Number Placeholder 0"/>
-          <p:cNvSpPr>
-            <a:spLocks noGrp="1"/>
-          </p:cNvSpPr>
-          <p:nvPr>
-            <p:ph type="sldNum" sz="quarter" idx="4294967295"/>
-          </p:nvPr>
-        </p:nvSpPr>
-        <p:spPr>
-          <a:xfrm>
-            <a:off x="27432" y="91440"/>
-            <a:ext cx="585216" cy="475488"/>
-          </a:xfrm>
-          <a:prstGeom prst="rect">
-            <a:avLst/>
-          </a:prstGeom>
-          <a:extLst>
-            <a:ext uri="{C572A759-6A51-4108-AA02-DFA0A04FC94B}">
-              <ma14:wrappingTextBoxFlag xmlns:ma14="http://schemas.microsoft.com/office/mac/drawingml/2011/main" val="0"/>
-            </a:ext>
-          </a:extLst>
-        </p:spPr>
-        <p:txBody>
-          <a:bodyPr/>
-          <a:lstStyle>
-            <a:lvl1pPr>
-              <a:defRPr sz="2000">
-                <a:solidFill>
-                  <a:srgbClr val="FFFFFF"/>
-                </a:solidFill>
-                <a:latin typeface="Calibri"/>
-                <a:ea typeface="Calibri"/>
-                <a:cs typeface="Calibri"/>
-              </a:defRPr>
-            </a:lvl1pPr>
-          </a:lstStyle>
-          <a:p>
-            <a:pPr algn="ctr"/>
-            <a:fld id="{F7021451-1387-4CA6-816F-3879F97B5CBC}" type="slidenum">
-              <a:rPr b="1" lang="en-US"/>
-              <a:t>59</a:t>
-            </a:fld>
-            <a:endParaRPr lang="en-US"/>
-          </a:p>
-        </p:txBody>
-      </p:sp>
-    </p:spTree>
-  </p:cSld>
-  <p:clrMapOvr>
-    <a:masterClrMapping/>
-  </p:clrMapOvr>
-</p:sld>
-</file>
-
-<file path=ppt/slides/slide6.xml><?xml version="1.0" encoding="utf-8"?>
-<p:sld xmlns:a="http://schemas.openxmlformats.org/drawingml/2006/main" xmlns:r="http://schemas.openxmlformats.org/officeDocument/2006/relationships" xmlns:p="http://schemas.openxmlformats.org/presentationml/2006/main">
-  <p:cSld name="Slide 6">
-    <p:spTree>
-      <p:nvGrpSpPr>
-        <p:cNvPr id="1" name=""/>
-        <p:cNvGrpSpPr/>
-        <p:nvPr/>
-      </p:nvGrpSpPr>
-      <p:grpSpPr>
-        <a:xfrm>
-          <a:off x="0" y="0"/>
-          <a:ext cx="0" cy="0"/>
-          <a:chOff x="0" y="0"/>
-          <a:chExt cx="0" cy="0"/>
-        </a:xfrm>
-      </p:grpSpPr>
-      <p:sp>
-        <p:nvSpPr>
-          <p:cNvPr id="2" name="Text 0"/>
-          <p:cNvSpPr/>
-          <p:nvPr/>
-        </p:nvSpPr>
-        <p:spPr>
-          <a:xfrm>
-            <a:off x="457200" y="713232"/>
-            <a:ext cx="11368735" cy="274320"/>
-          </a:xfrm>
-          <a:prstGeom prst="rect">
-            <a:avLst/>
-          </a:prstGeom>
-          <a:noFill/>
-          <a:ln/>
-        </p:spPr>
-        <p:txBody>
-          <a:bodyPr wrap="square" lIns="0" tIns="0" rIns="0" bIns="0" rtlCol="0" anchor="ctr"/>
-          <a:lstStyle/>
-          <a:p>
-            <a:pPr algn="r" indent="0" marL="0">
-              <a:buNone/>
-            </a:pPr>
-            <a:r>
-              <a:rPr lang="en-US" sz="1400" b="1" dirty="0">
-                <a:solidFill>
-                  <a:srgbClr val="1C3F6E"/>
-                </a:solidFill>
-                <a:latin typeface="Calibri" pitchFamily="34" charset="0"/>
-                <a:ea typeface="Calibri" pitchFamily="34" charset="-122"/>
-                <a:cs typeface="Calibri" pitchFamily="34" charset="-120"/>
-              </a:rPr>
-              <a:t>LESSON PLAN</a:t>
-            </a:r>
-            <a:endParaRPr lang="en-US" sz="1400" dirty="0"/>
-          </a:p>
-        </p:txBody>
-      </p:sp>
-      <p:pic>
-        <p:nvPicPr>
-          <p:cNvPr id="3" name="Image 0" descr="/home/claude/f4/img/minesec_sheet.png">    </p:cNvPr>
-          <p:cNvPicPr>
-            <a:picLocks noChangeAspect="1"/>
-          </p:cNvPicPr>
-          <p:nvPr/>
-        </p:nvPicPr>
-        <p:blipFill>
-          <a:blip r:embed="rId1"/>
-          <a:stretch>
-            <a:fillRect/>
-          </a:stretch>
-        </p:blipFill>
-        <p:spPr>
-          <a:xfrm>
-            <a:off x="0" y="658368"/>
-            <a:ext cx="2468880" cy="5833872"/>
-          </a:xfrm>
-          <a:prstGeom prst="rect">
-            <a:avLst/>
-          </a:prstGeom>
-        </p:spPr>
-      </p:pic>
-      <p:sp>
-        <p:nvSpPr>
-          <p:cNvPr id="4" name="Text 1"/>
-          <p:cNvSpPr/>
-          <p:nvPr/>
-        </p:nvSpPr>
-        <p:spPr>
-          <a:xfrm>
-            <a:off x="2697480" y="1005840"/>
-            <a:ext cx="9174175" cy="731520"/>
-          </a:xfrm>
-          <a:prstGeom prst="rect">
-            <a:avLst/>
-          </a:prstGeom>
-          <a:noFill/>
-          <a:ln/>
-        </p:spPr>
-        <p:txBody>
-          <a:bodyPr wrap="square" lIns="0" tIns="0" rIns="0" bIns="0" rtlCol="0" anchor="ctr">
-            <a:normAutofit/>
-          </a:bodyPr>
-          <a:lstStyle/>
-          <a:p>
-            <a:pPr algn="ctr" indent="0" marL="0">
-              <a:buNone/>
-            </a:pPr>
-            <a:r>
-              <a:rPr lang="en-US" sz="3600" b="1" dirty="0">
-                <a:solidFill>
-                  <a:srgbClr val="990011"/>
-                </a:solidFill>
-                <a:latin typeface="Times New Roman" pitchFamily="34" charset="0"/>
-                <a:ea typeface="Times New Roman" pitchFamily="34" charset="-122"/>
-                <a:cs typeface="Times New Roman" pitchFamily="34" charset="-120"/>
-              </a:rPr>
-              <a:t>Lesson Plan</a:t>
-            </a:r>
-            <a:endParaRPr lang="en-US" sz="3600" dirty="0"/>
-          </a:p>
-        </p:txBody>
-      </p:sp>
-      <p:sp>
-        <p:nvSpPr>
-          <p:cNvPr id="5" name="Text 2"/>
-          <p:cNvSpPr/>
-          <p:nvPr/>
-        </p:nvSpPr>
-        <p:spPr>
-          <a:xfrm>
-            <a:off x="2697480" y="1783080"/>
-            <a:ext cx="9174175" cy="4663440"/>
-          </a:xfrm>
-          <a:prstGeom prst="rect">
-            <a:avLst/>
-          </a:prstGeom>
-          <a:noFill/>
-          <a:ln/>
-        </p:spPr>
-        <p:txBody>
-          <a:bodyPr wrap="square" lIns="0" tIns="0" rIns="0" bIns="0" rtlCol="0" anchor="t"/>
-          <a:lstStyle/>
-          <a:p>
-            <a:pPr algn="l" marL="342900" indent="-342900">
-              <a:spcAft>
-                <a:spcPts val="800"/>
-              </a:spcAft>
-              <a:buSzPct val="100000"/>
-              <a:buFont typeface="+mj-lt"/>
-              <a:buAutoNum type="arabicPeriod" startAt="1"/>
-            </a:pPr>
-            <a:r>
-              <a:rPr lang="en-US" sz="4000" dirty="0">
-                <a:solidFill>
-                  <a:srgbClr val="111111"/>
-                </a:solidFill>
-                <a:latin typeface="Times New Roman" pitchFamily="34" charset="0"/>
-                <a:ea typeface="Times New Roman" pitchFamily="34" charset="-122"/>
-                <a:cs typeface="Times New Roman" pitchFamily="34" charset="-120"/>
-              </a:rPr>
-              <a:t>Correction of the homework</a:t>
-            </a:r>
-            <a:endParaRPr lang="en-US" sz="4000" dirty="0"/>
-          </a:p>
-          <a:p>
-            <a:pPr algn="l" marL="342900" indent="-342900">
-              <a:spcAft>
-                <a:spcPts val="800"/>
-              </a:spcAft>
-              <a:buSzPct val="100000"/>
-              <a:buFont typeface="+mj-lt"/>
-              <a:buAutoNum type="arabicPeriod" startAt="1"/>
-            </a:pPr>
-            <a:r>
-              <a:rPr lang="en-US" sz="4000" dirty="0">
-                <a:solidFill>
-                  <a:srgbClr val="111111"/>
-                </a:solidFill>
-                <a:latin typeface="Times New Roman" pitchFamily="34" charset="0"/>
-                <a:ea typeface="Times New Roman" pitchFamily="34" charset="-122"/>
-                <a:cs typeface="Times New Roman" pitchFamily="34" charset="-120"/>
-              </a:rPr>
-              <a:t>Objectives and recall</a:t>
-            </a:r>
-            <a:endParaRPr lang="en-US" sz="4000" dirty="0"/>
-          </a:p>
-          <a:p>
-            <a:pPr algn="l" marL="342900" indent="-342900">
-              <a:spcAft>
-                <a:spcPts val="800"/>
-              </a:spcAft>
-              <a:buSzPct val="100000"/>
-              <a:buFont typeface="+mj-lt"/>
-              <a:buAutoNum type="arabicPeriod" startAt="1"/>
-            </a:pPr>
-            <a:r>
-              <a:rPr lang="en-US" sz="4000" dirty="0">
-                <a:solidFill>
-                  <a:srgbClr val="111111"/>
-                </a:solidFill>
-                <a:latin typeface="Times New Roman" pitchFamily="34" charset="0"/>
-                <a:ea typeface="Times New Roman" pitchFamily="34" charset="-122"/>
-                <a:cs typeface="Times New Roman" pitchFamily="34" charset="-120"/>
-              </a:rPr>
-              <a:t>Real-life situation and action to take</a:t>
-            </a:r>
-            <a:endParaRPr lang="en-US" sz="4000" dirty="0"/>
-          </a:p>
-          <a:p>
-            <a:pPr algn="l" marL="342900" indent="-342900">
-              <a:spcAft>
-                <a:spcPts val="800"/>
-              </a:spcAft>
-              <a:buSzPct val="100000"/>
-              <a:buFont typeface="+mj-lt"/>
-              <a:buAutoNum type="arabicPeriod" startAt="1"/>
-            </a:pPr>
-            <a:r>
-              <a:rPr lang="en-US" sz="4000" dirty="0">
-                <a:solidFill>
-                  <a:srgbClr val="111111"/>
-                </a:solidFill>
-                <a:latin typeface="Times New Roman" pitchFamily="34" charset="0"/>
-                <a:ea typeface="Times New Roman" pitchFamily="34" charset="-122"/>
-                <a:cs typeface="Times New Roman" pitchFamily="34" charset="-120"/>
-              </a:rPr>
-              <a:t>Learning activities</a:t>
-            </a:r>
-            <a:endParaRPr lang="en-US" sz="4000" dirty="0"/>
-          </a:p>
-          <a:p>
-            <a:pPr algn="l" marL="342900" indent="-342900">
-              <a:spcAft>
-                <a:spcPts val="800"/>
-              </a:spcAft>
-              <a:buSzPct val="100000"/>
-              <a:buFont typeface="+mj-lt"/>
-              <a:buAutoNum type="arabicPeriod" startAt="1"/>
-            </a:pPr>
-            <a:r>
-              <a:rPr lang="en-US" sz="4000" dirty="0">
-                <a:solidFill>
-                  <a:srgbClr val="111111"/>
-                </a:solidFill>
-                <a:latin typeface="Times New Roman" pitchFamily="34" charset="0"/>
-                <a:ea typeface="Times New Roman" pitchFamily="34" charset="-122"/>
-                <a:cs typeface="Times New Roman" pitchFamily="34" charset="-120"/>
-              </a:rPr>
-              <a:t>Board summary</a:t>
-            </a:r>
-            <a:endParaRPr lang="en-US" sz="4000" dirty="0"/>
-          </a:p>
-          <a:p>
-            <a:pPr algn="l" marL="342900" indent="-342900">
-              <a:spcAft>
-                <a:spcPts val="800"/>
-              </a:spcAft>
-              <a:buSzPct val="100000"/>
-              <a:buFont typeface="+mj-lt"/>
-              <a:buAutoNum type="arabicPeriod" startAt="1"/>
-            </a:pPr>
-            <a:r>
-              <a:rPr lang="en-US" sz="4000" dirty="0">
-                <a:solidFill>
-                  <a:srgbClr val="111111"/>
-                </a:solidFill>
-                <a:latin typeface="Times New Roman" pitchFamily="34" charset="0"/>
-                <a:ea typeface="Times New Roman" pitchFamily="34" charset="-122"/>
-                <a:cs typeface="Times New Roman" pitchFamily="34" charset="-120"/>
-              </a:rPr>
-              <a:t>Evaluation, remediation and homework</a:t>
-            </a:r>
-            <a:endParaRPr lang="en-US" sz="4000" dirty="0"/>
-          </a:p>
-        </p:txBody>
-      </p:sp>
-      <p:sp>
-        <p:nvSpPr>
-          <p:cNvPr id="25" name="Slide Number Placeholder 0"/>
-          <p:cNvSpPr>
-            <a:spLocks noGrp="1"/>
-          </p:cNvSpPr>
-          <p:nvPr>
-            <p:ph type="sldNum" sz="quarter" idx="4294967295"/>
-          </p:nvPr>
-        </p:nvSpPr>
-        <p:spPr>
-          <a:xfrm>
-            <a:off x="27432" y="91440"/>
-            <a:ext cx="585216" cy="475488"/>
-          </a:xfrm>
-          <a:prstGeom prst="rect">
-            <a:avLst/>
-          </a:prstGeom>
-          <a:extLst>
-            <a:ext uri="{C572A759-6A51-4108-AA02-DFA0A04FC94B}">
-              <ma14:wrappingTextBoxFlag xmlns:ma14="http://schemas.microsoft.com/office/mac/drawingml/2011/main" val="0"/>
-            </a:ext>
-          </a:extLst>
-        </p:spPr>
-        <p:txBody>
-          <a:bodyPr/>
-          <a:lstStyle>
-            <a:lvl1pPr>
-              <a:defRPr sz="2000">
-                <a:solidFill>
-                  <a:srgbClr val="FFFFFF"/>
-                </a:solidFill>
-                <a:latin typeface="Calibri"/>
-                <a:ea typeface="Calibri"/>
-                <a:cs typeface="Calibri"/>
-              </a:defRPr>
-            </a:lvl1pPr>
-          </a:lstStyle>
-          <a:p>
-            <a:pPr algn="ctr"/>
-            <a:fld id="{F7021451-1387-4CA6-816F-3879F97B5CBC}" type="slidenum">
-              <a:rPr b="1" lang="en-US"/>
-              <a:t>6</a:t>
-            </a:fld>
-            <a:endParaRPr lang="en-US"/>
-          </a:p>
-        </p:txBody>
-      </p:sp>
-    </p:spTree>
-  </p:cSld>
-  <p:clrMapOvr>
-    <a:masterClrMapping/>
-  </p:clrMapOvr>
-</p:sld>
-</file>
-
-<file path=ppt/slides/slide60.xml><?xml version="1.0" encoding="utf-8"?>
-<p:sld xmlns:a="http://schemas.openxmlformats.org/drawingml/2006/main" xmlns:r="http://schemas.openxmlformats.org/officeDocument/2006/relationships" xmlns:p="http://schemas.openxmlformats.org/presentationml/2006/main">
-  <p:cSld name="Slide 60">
-    <p:spTree>
-      <p:nvGrpSpPr>
-        <p:cNvPr id="1" name=""/>
-        <p:cNvGrpSpPr/>
-        <p:nvPr/>
-      </p:nvGrpSpPr>
-      <p:grpSpPr>
-        <a:xfrm>
-          <a:off x="0" y="0"/>
-          <a:ext cx="0" cy="0"/>
-          <a:chOff x="0" y="0"/>
-          <a:chExt cx="0" cy="0"/>
-        </a:xfrm>
-      </p:grpSpPr>
-      <p:sp>
-        <p:nvSpPr>
-          <p:cNvPr id="2" name="Text 0"/>
-          <p:cNvSpPr/>
-          <p:nvPr/>
-        </p:nvSpPr>
-        <p:spPr>
-          <a:xfrm>
-            <a:off x="457200" y="713232"/>
-            <a:ext cx="11368735" cy="274320"/>
-          </a:xfrm>
-          <a:prstGeom prst="rect">
-            <a:avLst/>
-          </a:prstGeom>
-          <a:noFill/>
-          <a:ln/>
-        </p:spPr>
-        <p:txBody>
-          <a:bodyPr wrap="square" lIns="0" tIns="0" rIns="0" bIns="0" rtlCol="0" anchor="ctr"/>
-          <a:lstStyle/>
-          <a:p>
-            <a:pPr algn="r" indent="0" marL="0">
-              <a:buNone/>
-            </a:pPr>
-            <a:r>
-              <a:rPr lang="en-US" sz="1400" b="1" dirty="0">
-                <a:solidFill>
-                  <a:srgbClr val="1C3F6E"/>
-                </a:solidFill>
-                <a:latin typeface="Calibri" pitchFamily="34" charset="0"/>
-                <a:ea typeface="Calibri" pitchFamily="34" charset="-122"/>
-                <a:cs typeface="Calibri" pitchFamily="34" charset="-120"/>
-              </a:rPr>
-              <a:t>BILINGUAL GAME</a:t>
-            </a:r>
-            <a:endParaRPr lang="en-US" sz="1400" dirty="0"/>
-          </a:p>
-        </p:txBody>
-      </p:sp>
-      <p:sp>
-        <p:nvSpPr>
-          <p:cNvPr id="3" name="Text 1"/>
-          <p:cNvSpPr/>
-          <p:nvPr/>
-        </p:nvSpPr>
-        <p:spPr>
-          <a:xfrm>
-            <a:off x="457200" y="1005840"/>
-            <a:ext cx="11277295" cy="731520"/>
-          </a:xfrm>
-          <a:prstGeom prst="rect">
-            <a:avLst/>
-          </a:prstGeom>
-          <a:noFill/>
-          <a:ln/>
-        </p:spPr>
-        <p:txBody>
-          <a:bodyPr wrap="square" lIns="0" tIns="0" rIns="0" bIns="0" rtlCol="0" anchor="ctr"/>
-          <a:lstStyle/>
-          <a:p>
-            <a:pPr algn="ctr" indent="0" marL="0">
-              <a:buNone/>
-            </a:pPr>
-            <a:r>
-              <a:rPr lang="en-US" sz="3600" b="1" dirty="0">
-                <a:solidFill>
-                  <a:srgbClr val="990011"/>
-                </a:solidFill>
-                <a:latin typeface="Times New Roman" pitchFamily="34" charset="0"/>
-                <a:ea typeface="Times New Roman" pitchFamily="34" charset="-122"/>
-                <a:cs typeface="Times New Roman" pitchFamily="34" charset="-120"/>
-              </a:rPr>
               <a:t>Bilingual Game (Jeu Bilingue)</a:t>
             </a:r>
             <a:endParaRPr lang="en-US" sz="3600" dirty="0"/>
@@ -22127,7 +20918,7 @@
       </p:sp>
       <p:graphicFrame>
         <p:nvGraphicFramePr>
-          <p:cNvPr id="61" name="Table 0"/>
+          <p:cNvPr id="59" name="Table 0"/>
           <p:cNvGraphicFramePr>
             <a:graphicFrameLocks noGrp="1"/>
           </p:cNvGraphicFramePr>
@@ -23163,7 +21954,7 @@
             <a:pPr algn="ctr"/>
             <a:fld id="{F7021451-1387-4CA6-816F-3879F97B5CBC}" type="slidenum">
               <a:rPr b="1" lang="en-US"/>
-              <a:t>60</a:t>
+              <a:t>58</a:t>
             </a:fld>
             <a:endParaRPr lang="en-US"/>
           </a:p>
@@ -23177,9 +21968,9 @@
 </p:sld>
 </file>
 
-<file path=ppt/slides/slide61.xml><?xml version="1.0" encoding="utf-8"?>
+<file path=ppt/slides/slide59.xml><?xml version="1.0" encoding="utf-8"?>
 <p:sld xmlns:a="http://schemas.openxmlformats.org/drawingml/2006/main" xmlns:r="http://schemas.openxmlformats.org/officeDocument/2006/relationships" xmlns:p="http://schemas.openxmlformats.org/presentationml/2006/main">
-  <p:cSld name="Slide 61">
+  <p:cSld name="Slide 59">
     <p:spTree>
       <p:nvGrpSpPr>
         <p:cNvPr id="1" name=""/>
@@ -23274,7 +22065,7 @@
       </p:sp>
       <p:graphicFrame>
         <p:nvGraphicFramePr>
-          <p:cNvPr id="62" name="Table 0"/>
+          <p:cNvPr id="60" name="Table 0"/>
           <p:cNvGraphicFramePr>
             <a:graphicFrameLocks noGrp="1"/>
           </p:cNvGraphicFramePr>
@@ -23896,7 +22687,7 @@
             <a:pPr algn="ctr"/>
             <a:fld id="{F7021451-1387-4CA6-816F-3879F97B5CBC}" type="slidenum">
               <a:rPr b="1" lang="en-US"/>
-              <a:t>61</a:t>
+              <a:t>59</a:t>
             </a:fld>
             <a:endParaRPr lang="en-US"/>
           </a:p>
@@ -23910,9 +22701,9 @@
 </p:sld>
 </file>
 
-<file path=ppt/slides/slide62.xml><?xml version="1.0" encoding="utf-8"?>
+<file path=ppt/slides/slide6.xml><?xml version="1.0" encoding="utf-8"?>
 <p:sld xmlns:a="http://schemas.openxmlformats.org/drawingml/2006/main" xmlns:r="http://schemas.openxmlformats.org/officeDocument/2006/relationships" xmlns:p="http://schemas.openxmlformats.org/presentationml/2006/main">
-  <p:cSld name="Slide 62">
+  <p:cSld name="Slide 6">
     <p:spTree>
       <p:nvGrpSpPr>
         <p:cNvPr id="1" name=""/>
@@ -23960,22 +22751,46 @@
                 <a:ea typeface="Calibri" pitchFamily="34" charset="-122"/>
                 <a:cs typeface="Calibri" pitchFamily="34" charset="-120"/>
               </a:rPr>
-              <a:t>LOGBOOK</a:t>
+              <a:t>LESSON PLAN</a:t>
             </a:r>
             <a:endParaRPr lang="en-US" sz="1400" dirty="0"/>
           </a:p>
         </p:txBody>
       </p:sp>
-      <p:sp>
-        <p:nvSpPr>
-          <p:cNvPr id="3" name="Text 1"/>
+      <p:pic>
+        <p:nvPicPr>
+          <p:cNvPr id="3" name="Image 0" descr="/home/claude/f4/img/minesec_sheet.png">    </p:cNvPr>
+          <p:cNvPicPr>
+            <a:picLocks noChangeAspect="1"/>
+          </p:cNvPicPr>
+          <p:nvPr/>
+        </p:nvPicPr>
+        <p:blipFill>
+          <a:blip r:embed="rId1"/>
+          <a:stretch>
+            <a:fillRect/>
+          </a:stretch>
+        </p:blipFill>
+        <p:spPr>
+          <a:xfrm>
+            <a:off x="0" y="658368"/>
+            <a:ext cx="2468880" cy="5833872"/>
+          </a:xfrm>
+          <a:prstGeom prst="rect">
+            <a:avLst/>
+          </a:prstGeom>
+        </p:spPr>
+      </p:pic>
+      <p:sp>
+        <p:nvSpPr>
+          <p:cNvPr id="4" name="Text 1"/>
           <p:cNvSpPr/>
           <p:nvPr/>
         </p:nvSpPr>
         <p:spPr>
           <a:xfrm>
-            <a:off x="457200" y="1005840"/>
-            <a:ext cx="11277295" cy="731520"/>
+            <a:off x="2697480" y="1005840"/>
+            <a:ext cx="9174175" cy="731520"/>
           </a:xfrm>
           <a:prstGeom prst="rect">
             <a:avLst/>
@@ -23984,7 +22799,9 @@
           <a:ln/>
         </p:spPr>
         <p:txBody>
-          <a:bodyPr wrap="square" lIns="0" tIns="0" rIns="0" bIns="0" rtlCol="0" anchor="ctr"/>
+          <a:bodyPr wrap="square" lIns="0" tIns="0" rIns="0" bIns="0" rtlCol="0" anchor="ctr">
+            <a:normAutofit/>
+          </a:bodyPr>
           <a:lstStyle/>
           <a:p>
             <a:pPr algn="ctr" indent="0" marL="0">
@@ -23999,6 +22816,311 @@
                 <a:ea typeface="Times New Roman" pitchFamily="34" charset="-122"/>
                 <a:cs typeface="Times New Roman" pitchFamily="34" charset="-120"/>
               </a:rPr>
+              <a:t>Lesson Plan</a:t>
+            </a:r>
+            <a:endParaRPr lang="en-US" sz="3600" dirty="0"/>
+          </a:p>
+        </p:txBody>
+      </p:sp>
+      <p:sp>
+        <p:nvSpPr>
+          <p:cNvPr id="5" name="Text 2"/>
+          <p:cNvSpPr/>
+          <p:nvPr/>
+        </p:nvSpPr>
+        <p:spPr>
+          <a:xfrm>
+            <a:off x="2697480" y="1783080"/>
+            <a:ext cx="9174175" cy="4663440"/>
+          </a:xfrm>
+          <a:prstGeom prst="rect">
+            <a:avLst/>
+          </a:prstGeom>
+          <a:noFill/>
+          <a:ln/>
+        </p:spPr>
+        <p:txBody>
+          <a:bodyPr wrap="square" lIns="0" tIns="0" rIns="0" bIns="0" rtlCol="0" anchor="t"/>
+          <a:lstStyle/>
+          <a:p>
+            <a:pPr algn="l" marL="342900" indent="-342900">
+              <a:spcAft>
+                <a:spcPts val="800"/>
+              </a:spcAft>
+              <a:buSzPct val="100000"/>
+              <a:buFont typeface="+mj-lt"/>
+              <a:buAutoNum type="arabicPeriod" startAt="1"/>
+            </a:pPr>
+            <a:r>
+              <a:rPr lang="en-US" sz="4000" dirty="0">
+                <a:solidFill>
+                  <a:srgbClr val="111111"/>
+                </a:solidFill>
+                <a:latin typeface="Times New Roman" pitchFamily="34" charset="0"/>
+                <a:ea typeface="Times New Roman" pitchFamily="34" charset="-122"/>
+                <a:cs typeface="Times New Roman" pitchFamily="34" charset="-120"/>
+              </a:rPr>
+              <a:t>Correction of the homework</a:t>
+            </a:r>
+            <a:endParaRPr lang="en-US" sz="4000" dirty="0"/>
+          </a:p>
+          <a:p>
+            <a:pPr algn="l" marL="342900" indent="-342900">
+              <a:spcAft>
+                <a:spcPts val="800"/>
+              </a:spcAft>
+              <a:buSzPct val="100000"/>
+              <a:buFont typeface="+mj-lt"/>
+              <a:buAutoNum type="arabicPeriod" startAt="1"/>
+            </a:pPr>
+            <a:r>
+              <a:rPr lang="en-US" sz="4000" dirty="0">
+                <a:solidFill>
+                  <a:srgbClr val="111111"/>
+                </a:solidFill>
+                <a:latin typeface="Times New Roman" pitchFamily="34" charset="0"/>
+                <a:ea typeface="Times New Roman" pitchFamily="34" charset="-122"/>
+                <a:cs typeface="Times New Roman" pitchFamily="34" charset="-120"/>
+              </a:rPr>
+              <a:t>Objectives and recall</a:t>
+            </a:r>
+            <a:endParaRPr lang="en-US" sz="4000" dirty="0"/>
+          </a:p>
+          <a:p>
+            <a:pPr algn="l" marL="342900" indent="-342900">
+              <a:spcAft>
+                <a:spcPts val="800"/>
+              </a:spcAft>
+              <a:buSzPct val="100000"/>
+              <a:buFont typeface="+mj-lt"/>
+              <a:buAutoNum type="arabicPeriod" startAt="1"/>
+            </a:pPr>
+            <a:r>
+              <a:rPr lang="en-US" sz="4000" dirty="0">
+                <a:solidFill>
+                  <a:srgbClr val="111111"/>
+                </a:solidFill>
+                <a:latin typeface="Times New Roman" pitchFamily="34" charset="0"/>
+                <a:ea typeface="Times New Roman" pitchFamily="34" charset="-122"/>
+                <a:cs typeface="Times New Roman" pitchFamily="34" charset="-120"/>
+              </a:rPr>
+              <a:t>Real-life situation and action to take</a:t>
+            </a:r>
+            <a:endParaRPr lang="en-US" sz="4000" dirty="0"/>
+          </a:p>
+          <a:p>
+            <a:pPr algn="l" marL="342900" indent="-342900">
+              <a:spcAft>
+                <a:spcPts val="800"/>
+              </a:spcAft>
+              <a:buSzPct val="100000"/>
+              <a:buFont typeface="+mj-lt"/>
+              <a:buAutoNum type="arabicPeriod" startAt="1"/>
+            </a:pPr>
+            <a:r>
+              <a:rPr lang="en-US" sz="4000" dirty="0">
+                <a:solidFill>
+                  <a:srgbClr val="111111"/>
+                </a:solidFill>
+                <a:latin typeface="Times New Roman" pitchFamily="34" charset="0"/>
+                <a:ea typeface="Times New Roman" pitchFamily="34" charset="-122"/>
+                <a:cs typeface="Times New Roman" pitchFamily="34" charset="-120"/>
+              </a:rPr>
+              <a:t>Learning activities</a:t>
+            </a:r>
+            <a:endParaRPr lang="en-US" sz="4000" dirty="0"/>
+          </a:p>
+          <a:p>
+            <a:pPr algn="l" marL="342900" indent="-342900">
+              <a:spcAft>
+                <a:spcPts val="800"/>
+              </a:spcAft>
+              <a:buSzPct val="100000"/>
+              <a:buFont typeface="+mj-lt"/>
+              <a:buAutoNum type="arabicPeriod" startAt="1"/>
+            </a:pPr>
+            <a:r>
+              <a:rPr lang="en-US" sz="4000" dirty="0">
+                <a:solidFill>
+                  <a:srgbClr val="111111"/>
+                </a:solidFill>
+                <a:latin typeface="Times New Roman" pitchFamily="34" charset="0"/>
+                <a:ea typeface="Times New Roman" pitchFamily="34" charset="-122"/>
+                <a:cs typeface="Times New Roman" pitchFamily="34" charset="-120"/>
+              </a:rPr>
+              <a:t>Board summary</a:t>
+            </a:r>
+            <a:endParaRPr lang="en-US" sz="4000" dirty="0"/>
+          </a:p>
+          <a:p>
+            <a:pPr algn="l" marL="342900" indent="-342900">
+              <a:spcAft>
+                <a:spcPts val="800"/>
+              </a:spcAft>
+              <a:buSzPct val="100000"/>
+              <a:buFont typeface="+mj-lt"/>
+              <a:buAutoNum type="arabicPeriod" startAt="1"/>
+            </a:pPr>
+            <a:r>
+              <a:rPr lang="en-US" sz="4000" dirty="0">
+                <a:solidFill>
+                  <a:srgbClr val="111111"/>
+                </a:solidFill>
+                <a:latin typeface="Times New Roman" pitchFamily="34" charset="0"/>
+                <a:ea typeface="Times New Roman" pitchFamily="34" charset="-122"/>
+                <a:cs typeface="Times New Roman" pitchFamily="34" charset="-120"/>
+              </a:rPr>
+              <a:t>Evaluation, remediation and homework</a:t>
+            </a:r>
+            <a:endParaRPr lang="en-US" sz="4000" dirty="0"/>
+          </a:p>
+        </p:txBody>
+      </p:sp>
+      <p:sp>
+        <p:nvSpPr>
+          <p:cNvPr id="25" name="Slide Number Placeholder 0"/>
+          <p:cNvSpPr>
+            <a:spLocks noGrp="1"/>
+          </p:cNvSpPr>
+          <p:nvPr>
+            <p:ph type="sldNum" sz="quarter" idx="4294967295"/>
+          </p:nvPr>
+        </p:nvSpPr>
+        <p:spPr>
+          <a:xfrm>
+            <a:off x="27432" y="91440"/>
+            <a:ext cx="585216" cy="475488"/>
+          </a:xfrm>
+          <a:prstGeom prst="rect">
+            <a:avLst/>
+          </a:prstGeom>
+          <a:extLst>
+            <a:ext uri="{C572A759-6A51-4108-AA02-DFA0A04FC94B}">
+              <ma14:wrappingTextBoxFlag xmlns:ma14="http://schemas.microsoft.com/office/mac/drawingml/2011/main" val="0"/>
+            </a:ext>
+          </a:extLst>
+        </p:spPr>
+        <p:txBody>
+          <a:bodyPr/>
+          <a:lstStyle>
+            <a:lvl1pPr>
+              <a:defRPr sz="2000">
+                <a:solidFill>
+                  <a:srgbClr val="FFFFFF"/>
+                </a:solidFill>
+                <a:latin typeface="Calibri"/>
+                <a:ea typeface="Calibri"/>
+                <a:cs typeface="Calibri"/>
+              </a:defRPr>
+            </a:lvl1pPr>
+          </a:lstStyle>
+          <a:p>
+            <a:pPr algn="ctr"/>
+            <a:fld id="{F7021451-1387-4CA6-816F-3879F97B5CBC}" type="slidenum">
+              <a:rPr b="1" lang="en-US"/>
+              <a:t>6</a:t>
+            </a:fld>
+            <a:endParaRPr lang="en-US"/>
+          </a:p>
+        </p:txBody>
+      </p:sp>
+    </p:spTree>
+  </p:cSld>
+  <p:clrMapOvr>
+    <a:masterClrMapping/>
+  </p:clrMapOvr>
+</p:sld>
+</file>
+
+<file path=ppt/slides/slide60.xml><?xml version="1.0" encoding="utf-8"?>
+<p:sld xmlns:a="http://schemas.openxmlformats.org/drawingml/2006/main" xmlns:r="http://schemas.openxmlformats.org/officeDocument/2006/relationships" xmlns:p="http://schemas.openxmlformats.org/presentationml/2006/main">
+  <p:cSld name="Slide 60">
+    <p:spTree>
+      <p:nvGrpSpPr>
+        <p:cNvPr id="1" name=""/>
+        <p:cNvGrpSpPr/>
+        <p:nvPr/>
+      </p:nvGrpSpPr>
+      <p:grpSpPr>
+        <a:xfrm>
+          <a:off x="0" y="0"/>
+          <a:ext cx="0" cy="0"/>
+          <a:chOff x="0" y="0"/>
+          <a:chExt cx="0" cy="0"/>
+        </a:xfrm>
+      </p:grpSpPr>
+      <p:sp>
+        <p:nvSpPr>
+          <p:cNvPr id="2" name="Text 0"/>
+          <p:cNvSpPr/>
+          <p:nvPr/>
+        </p:nvSpPr>
+        <p:spPr>
+          <a:xfrm>
+            <a:off x="457200" y="713232"/>
+            <a:ext cx="11368735" cy="274320"/>
+          </a:xfrm>
+          <a:prstGeom prst="rect">
+            <a:avLst/>
+          </a:prstGeom>
+          <a:noFill/>
+          <a:ln/>
+        </p:spPr>
+        <p:txBody>
+          <a:bodyPr wrap="square" lIns="0" tIns="0" rIns="0" bIns="0" rtlCol="0" anchor="ctr"/>
+          <a:lstStyle/>
+          <a:p>
+            <a:pPr algn="r" indent="0" marL="0">
+              <a:buNone/>
+            </a:pPr>
+            <a:r>
+              <a:rPr lang="en-US" sz="1400" b="1" dirty="0">
+                <a:solidFill>
+                  <a:srgbClr val="1C3F6E"/>
+                </a:solidFill>
+                <a:latin typeface="Calibri" pitchFamily="34" charset="0"/>
+                <a:ea typeface="Calibri" pitchFamily="34" charset="-122"/>
+                <a:cs typeface="Calibri" pitchFamily="34" charset="-120"/>
+              </a:rPr>
+              <a:t>LOGBOOK</a:t>
+            </a:r>
+            <a:endParaRPr lang="en-US" sz="1400" dirty="0"/>
+          </a:p>
+        </p:txBody>
+      </p:sp>
+      <p:sp>
+        <p:nvSpPr>
+          <p:cNvPr id="3" name="Text 1"/>
+          <p:cNvSpPr/>
+          <p:nvPr/>
+        </p:nvSpPr>
+        <p:spPr>
+          <a:xfrm>
+            <a:off x="457200" y="1005840"/>
+            <a:ext cx="11277295" cy="731520"/>
+          </a:xfrm>
+          <a:prstGeom prst="rect">
+            <a:avLst/>
+          </a:prstGeom>
+          <a:noFill/>
+          <a:ln/>
+        </p:spPr>
+        <p:txBody>
+          <a:bodyPr wrap="square" lIns="0" tIns="0" rIns="0" bIns="0" rtlCol="0" anchor="ctr"/>
+          <a:lstStyle/>
+          <a:p>
+            <a:pPr algn="ctr" indent="0" marL="0">
+              <a:buNone/>
+            </a:pPr>
+            <a:r>
+              <a:rPr lang="en-US" sz="3600" b="1" dirty="0">
+                <a:solidFill>
+                  <a:srgbClr val="990011"/>
+                </a:solidFill>
+                <a:latin typeface="Times New Roman" pitchFamily="34" charset="0"/>
+                <a:ea typeface="Times New Roman" pitchFamily="34" charset="-122"/>
+                <a:cs typeface="Times New Roman" pitchFamily="34" charset="-120"/>
+              </a:rPr>
               <a:t>Official Logbook (2/2)</a:t>
             </a:r>
             <a:endParaRPr lang="en-US" sz="3600" dirty="0"/>
@@ -24007,7 +23129,7 @@
       </p:sp>
       <p:graphicFrame>
         <p:nvGraphicFramePr>
-          <p:cNvPr id="63" name="Table 0"/>
+          <p:cNvPr id="61" name="Table 0"/>
           <p:cNvGraphicFramePr>
             <a:graphicFrameLocks noGrp="1"/>
           </p:cNvGraphicFramePr>
@@ -24117,7 +23239,7 @@
                           <a:ea typeface="Calibri" pitchFamily="34" charset="-122"/>
                           <a:cs typeface="Calibri" pitchFamily="34" charset="-120"/>
                         </a:rPr>
-                        <a:t>DEFINITIONS; Introduction to Geomorphology; The Big Bang Theory; The Precambrian and the Palaeozoic; The Mesozoic and the Cenozoic.</a:t>
+                        <a:t>DEFINITIONS; Meaning of Geomorphology; The Big Bang Theory; The Precambrian and the Palaeozoic; The Mesozoic and the Cenozoic.</a:t>
                       </a:r>
                       <a:endParaRPr lang="en-US" sz="1600" dirty="0">
                         <a:latin typeface="Calibri" charset="0"/>
@@ -24767,7 +23889,7 @@
             <a:pPr algn="ctr"/>
             <a:fld id="{F7021451-1387-4CA6-816F-3879F97B5CBC}" type="slidenum">
               <a:rPr b="1" lang="en-US"/>
-              <a:t>62</a:t>
+              <a:t>60</a:t>
             </a:fld>
             <a:endParaRPr lang="en-US"/>
           </a:p>
@@ -24781,9 +23903,9 @@
 </p:sld>
 </file>
 
-<file path=ppt/slides/slide63.xml><?xml version="1.0" encoding="utf-8"?>
+<file path=ppt/slides/slide61.xml><?xml version="1.0" encoding="utf-8"?>
 <p:sld xmlns:a="http://schemas.openxmlformats.org/drawingml/2006/main" xmlns:r="http://schemas.openxmlformats.org/officeDocument/2006/relationships" xmlns:p="http://schemas.openxmlformats.org/presentationml/2006/main">
-  <p:cSld name="Slide 63">
+  <p:cSld name="Slide 61">
     <p:spTree>
       <p:nvGrpSpPr>
         <p:cNvPr id="1" name=""/>
@@ -25092,7 +24214,7 @@
             <a:pPr algn="ctr"/>
             <a:fld id="{F7021451-1387-4CA6-816F-3879F97B5CBC}" type="slidenum">
               <a:rPr b="1" lang="en-US"/>
-              <a:t>63</a:t>
+              <a:t>61</a:t>
             </a:fld>
             <a:endParaRPr lang="en-US"/>
           </a:p>
@@ -25106,9 +24228,9 @@
 </p:sld>
 </file>
 
-<file path=ppt/slides/slide64.xml><?xml version="1.0" encoding="utf-8"?>
+<file path=ppt/slides/slide62.xml><?xml version="1.0" encoding="utf-8"?>
 <p:sld xmlns:a="http://schemas.openxmlformats.org/drawingml/2006/main" xmlns:r="http://schemas.openxmlformats.org/officeDocument/2006/relationships" xmlns:p="http://schemas.openxmlformats.org/presentationml/2006/main">
-  <p:cSld name="Slide 64">
+  <p:cSld name="Slide 62">
     <p:spTree>
       <p:nvGrpSpPr>
         <p:cNvPr id="1" name=""/>
@@ -25348,7 +24470,7 @@
                 <a:ea typeface="Calibri" pitchFamily="34" charset="-122"/>
                 <a:cs typeface="Calibri" pitchFamily="34" charset="-120"/>
               </a:rPr>
-              <a:t>Photo, board summary (Life in the Precambrian): “Western Australia, Stromatolites Sharks Bay” by VladPix, CC BY-NC-ND 2.0, via Flickr (https://www.flickr.com/photos/62825712@N07/8766549873)</a:t>
+              <a:t>Photo, board summary (Precambrian (4,600 to 541 million years ago)): “Western Australia, Stromatolites Sharks Bay” by VladPix, CC BY-NC-ND 2.0, via Flickr (https://www.flickr.com/photos/62825712@N07/8766549873)</a:t>
             </a:r>
             <a:endParaRPr lang="en-US" sz="1800" dirty="0"/>
           </a:p>
@@ -25369,7 +24491,7 @@
                 <a:ea typeface="Calibri" pitchFamily="34" charset="-122"/>
                 <a:cs typeface="Calibri" pitchFamily="34" charset="-120"/>
               </a:rPr>
-              <a:t>Photo, board summary (Palaeozoic ("ancient life", 541–252 million years ago)): “Trilobite Fossil at NMNH” by Mr.TinDC, CC BY-ND 2.0, via Flickr (https://www.flickr.com/photos/7471115@N08/2948579998)</a:t>
+              <a:t>Photo, board summary (Palaeozoic (541 to 252 million years ago)): “Trilobite Fossil at NMNH” by Mr.TinDC, CC BY-ND 2.0, via Flickr (https://www.flickr.com/photos/7471115@N08/2948579998)</a:t>
             </a:r>
             <a:endParaRPr lang="en-US" sz="1800" dirty="0"/>
           </a:p>
@@ -25438,7 +24560,7 @@
             <a:pPr algn="ctr"/>
             <a:fld id="{F7021451-1387-4CA6-816F-3879F97B5CBC}" type="slidenum">
               <a:rPr b="1" lang="en-US"/>
-              <a:t>64</a:t>
+              <a:t>62</a:t>
             </a:fld>
             <a:endParaRPr lang="en-US"/>
           </a:p>

</xml_diff>